<commit_message>
pitch: HUD screenshots + end-to-end flow diagram + terminal log; embedded in deck
</commit_message>
<xml_diff>
--- a/docs/Cue-Pitch.pptx
+++ b/docs/Cue-Pitch.pptx
@@ -14,6 +14,8 @@
     <p:sldId id="262" r:id="rId13"/>
     <p:sldId id="263" r:id="rId14"/>
     <p:sldId id="264" r:id="rId15"/>
+    <p:sldId id="265" r:id="rId16"/>
+    <p:sldId id="266" r:id="rId17"/>
   </p:sldIdLst>
   <p:sldSz cx="12191695" cy="6858000" type="screen4x3"/>
   <p:notesSz cx="6858000" cy="9144000"/>
@@ -3217,6 +3219,356 @@
 </p:sld>
 </file>
 
+<file path=ppt/slides/slide10.xml><?xml version="1.0" encoding="utf-8"?>
+<p:sld xmlns:a="http://schemas.openxmlformats.org/drawingml/2006/main" xmlns:p="http://schemas.openxmlformats.org/presentationml/2006/main" xmlns:r="http://schemas.openxmlformats.org/officeDocument/2006/relationships">
+  <p:cSld>
+    <p:bg>
+      <p:bgPr>
+        <a:solidFill>
+          <a:srgbClr val="FAFAFA"/>
+        </a:solidFill>
+        <a:effectLst/>
+      </p:bgPr>
+    </p:bg>
+    <p:spTree>
+      <p:nvGrpSpPr>
+        <p:cNvPr id="1" name=""/>
+        <p:cNvGrpSpPr/>
+        <p:nvPr/>
+      </p:nvGrpSpPr>
+      <p:grpSpPr/>
+      <p:sp>
+        <p:nvSpPr>
+          <p:cNvPr id="2" name="TextBox 1"/>
+          <p:cNvSpPr txBox="1"/>
+          <p:nvPr/>
+        </p:nvSpPr>
+        <p:spPr>
+          <a:xfrm>
+            <a:off x="640080" y="548640"/>
+            <a:ext cx="10972800" cy="457200"/>
+          </a:xfrm>
+          <a:prstGeom prst="rect">
+            <a:avLst/>
+          </a:prstGeom>
+          <a:noFill/>
+        </p:spPr>
+        <p:txBody>
+          <a:bodyPr wrap="square" lIns="0" rIns="0">
+            <a:spAutoFit/>
+          </a:bodyPr>
+          <a:lstStyle/>
+          <a:p>
+            <a:pPr algn="l"/>
+            <a:r>
+              <a:rPr sz="1200" b="1">
+                <a:solidFill>
+                  <a:srgbClr val="00B86F"/>
+                </a:solidFill>
+                <a:latin typeface="Helvetica"/>
+              </a:rPr>
+              <a:t>WHY PEOPLE'S CHOICE</a:t>
+            </a:r>
+          </a:p>
+        </p:txBody>
+      </p:sp>
+      <p:sp>
+        <p:nvSpPr>
+          <p:cNvPr id="3" name="TextBox 2"/>
+          <p:cNvSpPr txBox="1"/>
+          <p:nvPr/>
+        </p:nvSpPr>
+        <p:spPr>
+          <a:xfrm>
+            <a:off x="640080" y="1097280"/>
+            <a:ext cx="10972800" cy="914400"/>
+          </a:xfrm>
+          <a:prstGeom prst="rect">
+            <a:avLst/>
+          </a:prstGeom>
+          <a:noFill/>
+        </p:spPr>
+        <p:txBody>
+          <a:bodyPr wrap="square" lIns="0" rIns="0">
+            <a:spAutoFit/>
+          </a:bodyPr>
+          <a:lstStyle/>
+          <a:p>
+            <a:pPr algn="l"/>
+            <a:r>
+              <a:rPr sz="4400" b="1">
+                <a:solidFill>
+                  <a:srgbClr val="0E0E0E"/>
+                </a:solidFill>
+                <a:latin typeface="Helvetica"/>
+              </a:rPr>
+              <a:t>Cue is the room.</a:t>
+            </a:r>
+          </a:p>
+        </p:txBody>
+      </p:sp>
+      <p:sp>
+        <p:nvSpPr>
+          <p:cNvPr id="4" name="TextBox 3"/>
+          <p:cNvSpPr txBox="1"/>
+          <p:nvPr/>
+        </p:nvSpPr>
+        <p:spPr>
+          <a:xfrm>
+            <a:off x="640080" y="2560320"/>
+            <a:ext cx="10972800" cy="3657600"/>
+          </a:xfrm>
+          <a:prstGeom prst="rect">
+            <a:avLst/>
+          </a:prstGeom>
+          <a:noFill/>
+        </p:spPr>
+        <p:txBody>
+          <a:bodyPr wrap="square">
+            <a:spAutoFit/>
+          </a:bodyPr>
+          <a:lstStyle/>
+          <a:p>
+            <a:pPr algn="l">
+              <a:spcAft>
+                <a:spcPts val="800"/>
+              </a:spcAft>
+            </a:pPr>
+            <a:r>
+              <a:rPr sz="2000">
+                <a:solidFill>
+                  <a:srgbClr val="0E0E0E"/>
+                </a:solidFill>
+                <a:latin typeface="Helvetica"/>
+              </a:rPr>
+              <a:t>—  Every judge forgot someone's name this week. Felt the micro-panic.</a:t>
+            </a:r>
+          </a:p>
+          <a:p>
+            <a:pPr algn="l">
+              <a:spcAft>
+                <a:spcPts val="800"/>
+              </a:spcAft>
+            </a:pPr>
+            <a:r>
+              <a:rPr sz="2000">
+                <a:solidFill>
+                  <a:srgbClr val="0E0E0E"/>
+                </a:solidFill>
+                <a:latin typeface="Helvetica"/>
+              </a:rPr>
+              <a:t>—  Every audience member is re-living it as pre-seeded teammates walk up.</a:t>
+            </a:r>
+          </a:p>
+          <a:p>
+            <a:pPr algn="l">
+              <a:spcAft>
+                <a:spcPts val="800"/>
+              </a:spcAft>
+            </a:pPr>
+            <a:r>
+              <a:rPr sz="2000">
+                <a:solidFill>
+                  <a:srgbClr val="0E0E0E"/>
+                </a:solidFill>
+                <a:latin typeface="Helvetica"/>
+              </a:rPr>
+              <a:t>—  Tagline repeats itself: "Meta Ray-Bans remember faces. Cue remembers people."</a:t>
+            </a:r>
+          </a:p>
+          <a:p>
+            <a:pPr algn="l">
+              <a:spcAft>
+                <a:spcPts val="800"/>
+              </a:spcAft>
+            </a:pPr>
+            <a:r>
+              <a:rPr sz="2000">
+                <a:solidFill>
+                  <a:srgbClr val="0E0E0E"/>
+                </a:solidFill>
+                <a:latin typeface="Helvetica"/>
+              </a:rPr>
+              <a:t>—  "Quiet Tech" rendered as product. Best Brand Fit fallback.</a:t>
+            </a:r>
+          </a:p>
+        </p:txBody>
+      </p:sp>
+    </p:spTree>
+  </p:cSld>
+  <p:clrMapOvr>
+    <a:masterClrMapping/>
+  </p:clrMapOvr>
+</p:sld>
+</file>
+
+<file path=ppt/slides/slide11.xml><?xml version="1.0" encoding="utf-8"?>
+<p:sld xmlns:a="http://schemas.openxmlformats.org/drawingml/2006/main" xmlns:p="http://schemas.openxmlformats.org/presentationml/2006/main" xmlns:r="http://schemas.openxmlformats.org/officeDocument/2006/relationships">
+  <p:cSld>
+    <p:bg>
+      <p:bgPr>
+        <a:solidFill>
+          <a:srgbClr val="111827"/>
+        </a:solidFill>
+        <a:effectLst/>
+      </p:bgPr>
+    </p:bg>
+    <p:spTree>
+      <p:nvGrpSpPr>
+        <p:cNvPr id="1" name=""/>
+        <p:cNvGrpSpPr/>
+        <p:nvPr/>
+      </p:nvGrpSpPr>
+      <p:grpSpPr/>
+      <p:sp>
+        <p:nvSpPr>
+          <p:cNvPr id="2" name="TextBox 1"/>
+          <p:cNvSpPr txBox="1"/>
+          <p:nvPr/>
+        </p:nvSpPr>
+        <p:spPr>
+          <a:xfrm>
+            <a:off x="640080" y="1371600"/>
+            <a:ext cx="10972800" cy="1097280"/>
+          </a:xfrm>
+          <a:prstGeom prst="rect">
+            <a:avLst/>
+          </a:prstGeom>
+          <a:noFill/>
+        </p:spPr>
+        <p:txBody>
+          <a:bodyPr wrap="square" lIns="0" rIns="0">
+            <a:spAutoFit/>
+          </a:bodyPr>
+          <a:lstStyle/>
+          <a:p>
+            <a:pPr algn="ctr"/>
+            <a:r>
+              <a:rPr sz="5600" b="1">
+                <a:solidFill>
+                  <a:srgbClr val="FFFFFF"/>
+                </a:solidFill>
+                <a:latin typeface="Helvetica"/>
+              </a:rPr>
+              <a:t>Faces are data.</a:t>
+            </a:r>
+          </a:p>
+        </p:txBody>
+      </p:sp>
+      <p:sp>
+        <p:nvSpPr>
+          <p:cNvPr id="3" name="TextBox 2"/>
+          <p:cNvSpPr txBox="1"/>
+          <p:nvPr/>
+        </p:nvSpPr>
+        <p:spPr>
+          <a:xfrm>
+            <a:off x="640080" y="2560320"/>
+            <a:ext cx="10972800" cy="1097280"/>
+          </a:xfrm>
+          <a:prstGeom prst="rect">
+            <a:avLst/>
+          </a:prstGeom>
+          <a:noFill/>
+        </p:spPr>
+        <p:txBody>
+          <a:bodyPr wrap="square" lIns="0" rIns="0">
+            <a:spAutoFit/>
+          </a:bodyPr>
+          <a:lstStyle/>
+          <a:p>
+            <a:pPr algn="ctr"/>
+            <a:r>
+              <a:rPr sz="5600" b="1">
+                <a:solidFill>
+                  <a:srgbClr val="00B86F"/>
+                </a:solidFill>
+                <a:latin typeface="Helvetica"/>
+              </a:rPr>
+              <a:t>People are memory.</a:t>
+            </a:r>
+          </a:p>
+        </p:txBody>
+      </p:sp>
+      <p:sp>
+        <p:nvSpPr>
+          <p:cNvPr id="4" name="TextBox 3"/>
+          <p:cNvSpPr txBox="1"/>
+          <p:nvPr/>
+        </p:nvSpPr>
+        <p:spPr>
+          <a:xfrm>
+            <a:off x="640080" y="4206240"/>
+            <a:ext cx="10972800" cy="731520"/>
+          </a:xfrm>
+          <a:prstGeom prst="rect">
+            <a:avLst/>
+          </a:prstGeom>
+          <a:noFill/>
+        </p:spPr>
+        <p:txBody>
+          <a:bodyPr wrap="square" lIns="0" rIns="0">
+            <a:spAutoFit/>
+          </a:bodyPr>
+          <a:lstStyle/>
+          <a:p>
+            <a:pPr algn="ctr"/>
+            <a:r>
+              <a:rPr sz="2200" b="0">
+                <a:solidFill>
+                  <a:srgbClr val="DDDDDD"/>
+                </a:solidFill>
+                <a:latin typeface="Helvetica"/>
+              </a:rPr>
+              <a:t>G2 is the first wearable quiet enough
+to hold the second one.</a:t>
+            </a:r>
+          </a:p>
+        </p:txBody>
+      </p:sp>
+      <p:sp>
+        <p:nvSpPr>
+          <p:cNvPr id="5" name="TextBox 4"/>
+          <p:cNvSpPr txBox="1"/>
+          <p:nvPr/>
+        </p:nvSpPr>
+        <p:spPr>
+          <a:xfrm>
+            <a:off x="640080" y="6035040"/>
+            <a:ext cx="10972800" cy="365760"/>
+          </a:xfrm>
+          <a:prstGeom prst="rect">
+            <a:avLst/>
+          </a:prstGeom>
+          <a:noFill/>
+        </p:spPr>
+        <p:txBody>
+          <a:bodyPr wrap="square" lIns="0" rIns="0">
+            <a:spAutoFit/>
+          </a:bodyPr>
+          <a:lstStyle/>
+          <a:p>
+            <a:pPr algn="ctr"/>
+            <a:r>
+              <a:rPr sz="1400" b="0">
+                <a:solidFill>
+                  <a:srgbClr val="6B7280"/>
+                </a:solidFill>
+                <a:latin typeface="Helvetica"/>
+              </a:rPr>
+              <a:t>Thank you.  ·  github.com/abhishekj720/Cue-evenRealitiesG2</a:t>
+            </a:r>
+          </a:p>
+        </p:txBody>
+      </p:sp>
+    </p:spTree>
+  </p:cSld>
+  <p:clrMapOvr>
+    <a:masterClrMapping/>
+  </p:clrMapOvr>
+</p:sld>
+</file>
+
 <file path=ppt/slides/slide2.xml><?xml version="1.0" encoding="utf-8"?>
 <p:sld xmlns:a="http://schemas.openxmlformats.org/drawingml/2006/main" xmlns:p="http://schemas.openxmlformats.org/presentationml/2006/main" xmlns:r="http://schemas.openxmlformats.org/officeDocument/2006/relationships">
   <p:cSld>
@@ -3816,7 +4168,7 @@
         </p:nvSpPr>
         <p:spPr>
           <a:xfrm>
-            <a:off x="640080" y="548640"/>
+            <a:off x="640080" y="365760"/>
             <a:ext cx="10972800" cy="457200"/>
           </a:xfrm>
           <a:prstGeom prst="rect">
@@ -3851,8 +4203,8 @@
         </p:nvSpPr>
         <p:spPr>
           <a:xfrm>
-            <a:off x="640080" y="1005840"/>
-            <a:ext cx="10972800" cy="822960"/>
+            <a:off x="640080" y="822960"/>
+            <a:ext cx="10972800" cy="548640"/>
           </a:xfrm>
           <a:prstGeom prst="rect">
             <a:avLst/>
@@ -3867,269 +4219,65 @@
           <a:p>
             <a:pPr algn="l"/>
             <a:r>
-              <a:rPr sz="2000" b="0">
+              <a:rPr sz="1800" b="0">
                 <a:solidFill>
                   <a:srgbClr val="6B7280"/>
                 </a:solidFill>
                 <a:latin typeface="Helvetica"/>
               </a:rPr>
-              <a:t>One glanceable card. 576 x 288 pixels. Green on black.</a:t>
-            </a:r>
-          </a:p>
-        </p:txBody>
-      </p:sp>
-      <p:sp>
-        <p:nvSpPr>
-          <p:cNvPr id="4" name="Rectangle 3"/>
-          <p:cNvSpPr/>
+              <a:t>One glanceable card. 576 x 288 px. Green on black.</a:t>
+            </a:r>
+          </a:p>
+        </p:txBody>
+      </p:sp>
+      <p:pic>
+        <p:nvPicPr>
+          <p:cNvPr id="4" name="Picture 3" descr="03_match_abhishek@2x.png"/>
+          <p:cNvPicPr>
+            <a:picLocks noChangeAspect="1"/>
+          </p:cNvPicPr>
           <p:nvPr/>
-        </p:nvSpPr>
-        <p:spPr>
-          <a:xfrm>
-            <a:off x="640080" y="2103120"/>
-            <a:ext cx="5303520" cy="3200400"/>
+        </p:nvPicPr>
+        <p:blipFill>
+          <a:blip r:embed="rId2"/>
+          <a:stretch>
+            <a:fillRect/>
+          </a:stretch>
+        </p:blipFill>
+        <p:spPr>
+          <a:xfrm>
+            <a:off x="640080" y="1828800"/>
+            <a:ext cx="5120640" cy="2560320"/>
           </a:xfrm>
           <a:prstGeom prst="rect">
             <a:avLst/>
           </a:prstGeom>
-          <a:solidFill>
-            <a:srgbClr val="000000"/>
-          </a:solidFill>
-          <a:ln w="19050">
-            <a:solidFill>
-              <a:srgbClr val="00E83E"/>
-            </a:solidFill>
-          </a:ln>
-        </p:spPr>
-        <p:style>
-          <a:lnRef idx="1">
-            <a:schemeClr val="accent1"/>
-          </a:lnRef>
-          <a:fillRef idx="3">
-            <a:schemeClr val="accent1"/>
-          </a:fillRef>
-          <a:effectRef idx="2">
-            <a:schemeClr val="accent1"/>
-          </a:effectRef>
-          <a:fontRef idx="minor">
-            <a:schemeClr val="lt1"/>
-          </a:fontRef>
-        </p:style>
-        <p:txBody>
-          <a:bodyPr rtlCol="0" anchor="ctr" wrap="square" lIns="182880" rIns="182880" tIns="137160"/>
-          <a:lstStyle/>
-          <a:p>
-            <a:pPr algn="l"/>
-            <a:r>
-              <a:rPr sz="1800" b="1">
-                <a:solidFill>
-                  <a:srgbClr val="00E83E"/>
-                </a:solidFill>
-                <a:latin typeface="Menlo"/>
-              </a:rPr>
-              <a:t>Abhishek Jaiswal</a:t>
-            </a:r>
-          </a:p>
-          <a:p>
-            <a:pPr algn="l"/>
-            <a:r>
-              <a:rPr sz="1400">
-                <a:solidFill>
-                  <a:srgbClr val="00E83E"/>
-                </a:solidFill>
-                <a:latin typeface="Menlo"/>
-              </a:rPr>
-              <a:t>----------------------------</a:t>
-            </a:r>
-          </a:p>
-          <a:p>
-            <a:pPr algn="l"/>
-            <a:r>
-              <a:rPr sz="1400">
-                <a:solidFill>
-                  <a:srgbClr val="00E83E"/>
-                </a:solidFill>
-                <a:latin typeface="Menlo"/>
-              </a:rPr>
-              <a:t>Infra eng, Cue co-builder</a:t>
-            </a:r>
-          </a:p>
-          <a:p>
-            <a:pPr algn="l"/>
-            <a:r>
-              <a:rPr sz="1400">
-                <a:solidFill>
-                  <a:srgbClr val="00E83E"/>
-                </a:solidFill>
-                <a:latin typeface="Menlo"/>
-              </a:rPr>
-              <a:t>Pairing on demo-seed script</a:t>
-            </a:r>
-          </a:p>
-          <a:p>
-            <a:pPr algn="l"/>
-            <a:r>
-              <a:rPr sz="1400">
-                <a:solidFill>
-                  <a:srgbClr val="00E83E"/>
-                </a:solidFill>
-                <a:latin typeface="Menlo"/>
-              </a:rPr>
-              <a:t>Ask how the script pairing w</a:t>
-            </a:r>
-          </a:p>
-          <a:p>
-            <a:pPr algn="l"/>
-            <a:r>
-              <a:rPr sz="1400">
-                <a:solidFill>
-                  <a:srgbClr val="00E83E"/>
-                </a:solidFill>
-                <a:latin typeface="Menlo"/>
-              </a:rPr>
-              <a:t/>
-            </a:r>
-          </a:p>
-          <a:p>
-            <a:pPr algn="l"/>
-            <a:r>
-              <a:rPr sz="1400">
-                <a:solidFill>
-                  <a:srgbClr val="00E83E"/>
-                </a:solidFill>
-                <a:latin typeface="Menlo"/>
-              </a:rPr>
-              <a:t>seen 8 min ago</a:t>
-            </a:r>
-          </a:p>
-        </p:txBody>
-      </p:sp>
-      <p:sp>
-        <p:nvSpPr>
-          <p:cNvPr id="5" name="Rectangle 4"/>
-          <p:cNvSpPr/>
+        </p:spPr>
+      </p:pic>
+      <p:pic>
+        <p:nvPicPr>
+          <p:cNvPr id="5" name="Picture 4" descr="05_match_priya@2x.png"/>
+          <p:cNvPicPr>
+            <a:picLocks noChangeAspect="1"/>
+          </p:cNvPicPr>
           <p:nvPr/>
-        </p:nvSpPr>
-        <p:spPr>
-          <a:xfrm>
-            <a:off x="6263640" y="2103120"/>
-            <a:ext cx="5303520" cy="3200400"/>
+        </p:nvPicPr>
+        <p:blipFill>
+          <a:blip r:embed="rId3"/>
+          <a:stretch>
+            <a:fillRect/>
+          </a:stretch>
+        </p:blipFill>
+        <p:spPr>
+          <a:xfrm>
+            <a:off x="6400800" y="1828800"/>
+            <a:ext cx="5120640" cy="2560320"/>
           </a:xfrm>
           <a:prstGeom prst="rect">
             <a:avLst/>
           </a:prstGeom>
-          <a:solidFill>
-            <a:srgbClr val="000000"/>
-          </a:solidFill>
-          <a:ln w="19050">
-            <a:solidFill>
-              <a:srgbClr val="00E83E"/>
-            </a:solidFill>
-          </a:ln>
-        </p:spPr>
-        <p:style>
-          <a:lnRef idx="1">
-            <a:schemeClr val="accent1"/>
-          </a:lnRef>
-          <a:fillRef idx="3">
-            <a:schemeClr val="accent1"/>
-          </a:fillRef>
-          <a:effectRef idx="2">
-            <a:schemeClr val="accent1"/>
-          </a:effectRef>
-          <a:fontRef idx="minor">
-            <a:schemeClr val="lt1"/>
-          </a:fontRef>
-        </p:style>
-        <p:txBody>
-          <a:bodyPr rtlCol="0" anchor="ctr" wrap="square" lIns="182880" rIns="182880" tIns="137160"/>
-          <a:lstStyle/>
-          <a:p>
-            <a:pPr algn="l"/>
-            <a:r>
-              <a:rPr sz="1800" b="1">
-                <a:solidFill>
-                  <a:srgbClr val="00E83E"/>
-                </a:solidFill>
-                <a:latin typeface="Menlo"/>
-              </a:rPr>
-              <a:t>Priya Subramanian</a:t>
-            </a:r>
-          </a:p>
-          <a:p>
-            <a:pPr algn="l"/>
-            <a:r>
-              <a:rPr sz="1400">
-                <a:solidFill>
-                  <a:srgbClr val="00E83E"/>
-                </a:solidFill>
-                <a:latin typeface="Menlo"/>
-              </a:rPr>
-              <a:t>----------------------------</a:t>
-            </a:r>
-          </a:p>
-          <a:p>
-            <a:pPr algn="l"/>
-            <a:r>
-              <a:rPr sz="1400">
-                <a:solidFill>
-                  <a:srgbClr val="00E83E"/>
-                </a:solidFill>
-                <a:latin typeface="Menlo"/>
-              </a:rPr>
-              <a:t>PM design @ Acme, Q3 lead</a:t>
-            </a:r>
-          </a:p>
-          <a:p>
-            <a:pPr algn="l"/>
-            <a:r>
-              <a:rPr sz="1400">
-                <a:solidFill>
-                  <a:srgbClr val="00E83E"/>
-                </a:solidFill>
-                <a:latin typeface="Menlo"/>
-              </a:rPr>
-              <a:t>Owes you beta invite link</a:t>
-            </a:r>
-          </a:p>
-          <a:p>
-            <a:pPr algn="l"/>
-            <a:r>
-              <a:rPr sz="1400">
-                <a:solidFill>
-                  <a:srgbClr val="00E83E"/>
-                </a:solidFill>
-                <a:latin typeface="Menlo"/>
-              </a:rPr>
-              <a:t>Ask about onboarding friction</a:t>
-            </a:r>
-          </a:p>
-          <a:p>
-            <a:pPr algn="l"/>
-            <a:r>
-              <a:rPr sz="1400">
-                <a:solidFill>
-                  <a:srgbClr val="00E83E"/>
-                </a:solidFill>
-                <a:latin typeface="Menlo"/>
-              </a:rPr>
-              <a:t/>
-            </a:r>
-          </a:p>
-          <a:p>
-            <a:pPr algn="l"/>
-            <a:r>
-              <a:rPr sz="1400">
-                <a:solidFill>
-                  <a:srgbClr val="00E83E"/>
-                </a:solidFill>
-                <a:latin typeface="Menlo"/>
-              </a:rPr>
-              <a:t>seen 40 min ago</a:t>
-            </a:r>
-          </a:p>
-        </p:txBody>
-      </p:sp>
+        </p:spPr>
+      </p:pic>
       <p:sp>
         <p:nvSpPr>
           <p:cNvPr id="6" name="TextBox 5"/>
@@ -4138,7 +4286,7 @@
         </p:nvSpPr>
         <p:spPr>
           <a:xfrm>
-            <a:off x="640080" y="5669280"/>
+            <a:off x="640080" y="5577840"/>
             <a:ext cx="10972800" cy="457200"/>
           </a:xfrm>
           <a:prstGeom prst="rect">
@@ -4199,7 +4347,7 @@
         </p:nvSpPr>
         <p:spPr>
           <a:xfrm>
-            <a:off x="640080" y="548640"/>
+            <a:off x="640080" y="365760"/>
             <a:ext cx="10972800" cy="457200"/>
           </a:xfrm>
           <a:prstGeom prst="rect">
@@ -4221,7 +4369,7 @@
                 </a:solidFill>
                 <a:latin typeface="Helvetica"/>
               </a:rPr>
-              <a:t>HOW IT WORKS</a:t>
+              <a:t>END-TO-END HUD STATES</a:t>
             </a:r>
           </a:p>
         </p:txBody>
@@ -4234,8 +4382,8 @@
         </p:nvSpPr>
         <p:spPr>
           <a:xfrm>
-            <a:off x="640080" y="1005840"/>
-            <a:ext cx="10972800" cy="822960"/>
+            <a:off x="640080" y="822960"/>
+            <a:ext cx="10972800" cy="548640"/>
           </a:xfrm>
           <a:prstGeom prst="rect">
             <a:avLst/>
@@ -4250,27 +4398,51 @@
           <a:p>
             <a:pPr algn="l"/>
             <a:r>
-              <a:rPr sz="2400" b="1">
-                <a:solidFill>
-                  <a:srgbClr val="0E0E0E"/>
+              <a:rPr sz="1800" b="0">
+                <a:solidFill>
+                  <a:srgbClr val="6B7280"/>
                 </a:solidFill>
                 <a:latin typeface="Helvetica"/>
               </a:rPr>
-              <a:t>Local-first. Cameraless. Built in a day.</a:t>
-            </a:r>
-          </a:p>
-        </p:txBody>
-      </p:sp>
-      <p:sp>
-        <p:nvSpPr>
-          <p:cNvPr id="4" name="TextBox 3"/>
+              <a:t>Idle → match → another match → focus mode.</a:t>
+            </a:r>
+          </a:p>
+        </p:txBody>
+      </p:sp>
+      <p:pic>
+        <p:nvPicPr>
+          <p:cNvPr id="4" name="Picture 3" descr="01_idle@2x.png"/>
+          <p:cNvPicPr>
+            <a:picLocks noChangeAspect="1"/>
+          </p:cNvPicPr>
+          <p:nvPr/>
+        </p:nvPicPr>
+        <p:blipFill>
+          <a:blip r:embed="rId2"/>
+          <a:stretch>
+            <a:fillRect/>
+          </a:stretch>
+        </p:blipFill>
+        <p:spPr>
+          <a:xfrm>
+            <a:off x="548640" y="1645920"/>
+            <a:ext cx="5212080" cy="2606040"/>
+          </a:xfrm>
+          <a:prstGeom prst="rect">
+            <a:avLst/>
+          </a:prstGeom>
+        </p:spPr>
+      </p:pic>
+      <p:sp>
+        <p:nvSpPr>
+          <p:cNvPr id="5" name="TextBox 4"/>
           <p:cNvSpPr txBox="1"/>
           <p:nvPr/>
         </p:nvSpPr>
         <p:spPr>
           <a:xfrm>
-            <a:off x="640080" y="2377440"/>
-            <a:ext cx="10972800" cy="3657600"/>
+            <a:off x="548640" y="3977639"/>
+            <a:ext cx="5212080" cy="274320"/>
           </a:xfrm>
           <a:prstGeom prst="rect">
             <a:avLst/>
@@ -4278,102 +4450,58 @@
           <a:noFill/>
         </p:spPr>
         <p:txBody>
-          <a:bodyPr wrap="square">
+          <a:bodyPr wrap="square" lIns="0" rIns="0">
             <a:spAutoFit/>
           </a:bodyPr>
           <a:lstStyle/>
           <a:p>
-            <a:pPr algn="l">
-              <a:spcAft>
-                <a:spcPts val="800"/>
-              </a:spcAft>
-            </a:pPr>
-            <a:r>
-              <a:rPr sz="2200">
-                <a:solidFill>
-                  <a:srgbClr val="0E0E0E"/>
+            <a:pPr algn="ctr"/>
+            <a:r>
+              <a:rPr sz="1400" b="0">
+                <a:solidFill>
+                  <a:srgbClr val="6B7280"/>
                 </a:solidFill>
                 <a:latin typeface="Helvetica"/>
               </a:rPr>
-              <a:t>—  Phone mic     →  VAD segments speech</a:t>
-            </a:r>
-          </a:p>
-          <a:p>
-            <a:pPr algn="l">
-              <a:spcAft>
-                <a:spcPts val="800"/>
-              </a:spcAft>
-            </a:pPr>
-            <a:r>
-              <a:rPr sz="2200">
-                <a:solidFill>
-                  <a:srgbClr val="0E0E0E"/>
-                </a:solidFill>
-                <a:latin typeface="Helvetica"/>
-              </a:rPr>
-              <a:t>—  Segment       →  Resemblyzer 256-d voiceprint</a:t>
-            </a:r>
-          </a:p>
-          <a:p>
-            <a:pPr algn="l">
-              <a:spcAft>
-                <a:spcPts val="800"/>
-              </a:spcAft>
-            </a:pPr>
-            <a:r>
-              <a:rPr sz="2200">
-                <a:solidFill>
-                  <a:srgbClr val="0E0E0E"/>
-                </a:solidFill>
-                <a:latin typeface="Helvetica"/>
-              </a:rPr>
-              <a:t>—  Voiceprint    →  cosine match against SQLite (local, ~/.cue/people.db)</a:t>
-            </a:r>
-          </a:p>
-          <a:p>
-            <a:pPr algn="l">
-              <a:spcAft>
-                <a:spcPts val="800"/>
-              </a:spcAft>
-            </a:pPr>
-            <a:r>
-              <a:rPr sz="2200">
-                <a:solidFill>
-                  <a:srgbClr val="0E0E0E"/>
-                </a:solidFill>
-                <a:latin typeface="Helvetica"/>
-              </a:rPr>
-              <a:t>—  Match         →  Claude Haiku writes a 3-line brief</a:t>
-            </a:r>
-          </a:p>
-          <a:p>
-            <a:pPr algn="l">
-              <a:spcAft>
-                <a:spcPts val="800"/>
-              </a:spcAft>
-            </a:pPr>
-            <a:r>
-              <a:rPr sz="2200">
-                <a:solidFill>
-                  <a:srgbClr val="0E0E0E"/>
-                </a:solidFill>
-                <a:latin typeface="Helvetica"/>
-              </a:rPr>
-              <a:t>—  Brief         →  HUD card via Even Hub SDK</a:t>
-            </a:r>
-          </a:p>
-        </p:txBody>
-      </p:sp>
-      <p:sp>
-        <p:nvSpPr>
-          <p:cNvPr id="5" name="TextBox 4"/>
+              <a:t>Idle</a:t>
+            </a:r>
+          </a:p>
+        </p:txBody>
+      </p:sp>
+      <p:pic>
+        <p:nvPicPr>
+          <p:cNvPr id="6" name="Picture 5" descr="03_match_abhishek@2x.png"/>
+          <p:cNvPicPr>
+            <a:picLocks noChangeAspect="1"/>
+          </p:cNvPicPr>
+          <p:nvPr/>
+        </p:nvPicPr>
+        <p:blipFill>
+          <a:blip r:embed="rId3"/>
+          <a:stretch>
+            <a:fillRect/>
+          </a:stretch>
+        </p:blipFill>
+        <p:spPr>
+          <a:xfrm>
+            <a:off x="6309360" y="1645920"/>
+            <a:ext cx="5212080" cy="2606040"/>
+          </a:xfrm>
+          <a:prstGeom prst="rect">
+            <a:avLst/>
+          </a:prstGeom>
+        </p:spPr>
+      </p:pic>
+      <p:sp>
+        <p:nvSpPr>
+          <p:cNvPr id="7" name="TextBox 6"/>
           <p:cNvSpPr txBox="1"/>
           <p:nvPr/>
         </p:nvSpPr>
         <p:spPr>
           <a:xfrm>
-            <a:off x="640080" y="5760720"/>
-            <a:ext cx="10972800" cy="457200"/>
+            <a:off x="6309360" y="3977639"/>
+            <a:ext cx="5212080" cy="274320"/>
           </a:xfrm>
           <a:prstGeom prst="rect">
             <a:avLst/>
@@ -4386,15 +4514,133 @@
           </a:bodyPr>
           <a:lstStyle/>
           <a:p>
-            <a:pPr algn="l"/>
-            <a:r>
-              <a:rPr sz="1600" b="0">
+            <a:pPr algn="ctr"/>
+            <a:r>
+              <a:rPr sz="1400" b="0">
                 <a:solidFill>
                   <a:srgbClr val="6B7280"/>
                 </a:solidFill>
                 <a:latin typeface="Helvetica"/>
               </a:rPr>
-              <a:t>No cloud sync. No camera. No face database. ≤1.5s median latency.</a:t>
+              <a:t>Match: Abhishek</a:t>
+            </a:r>
+          </a:p>
+        </p:txBody>
+      </p:sp>
+      <p:pic>
+        <p:nvPicPr>
+          <p:cNvPr id="8" name="Picture 7" descr="04_match_tim@2x.png"/>
+          <p:cNvPicPr>
+            <a:picLocks noChangeAspect="1"/>
+          </p:cNvPicPr>
+          <p:nvPr/>
+        </p:nvPicPr>
+        <p:blipFill>
+          <a:blip r:embed="rId4"/>
+          <a:stretch>
+            <a:fillRect/>
+          </a:stretch>
+        </p:blipFill>
+        <p:spPr>
+          <a:xfrm>
+            <a:off x="548640" y="4206240"/>
+            <a:ext cx="5212080" cy="2606040"/>
+          </a:xfrm>
+          <a:prstGeom prst="rect">
+            <a:avLst/>
+          </a:prstGeom>
+        </p:spPr>
+      </p:pic>
+      <p:sp>
+        <p:nvSpPr>
+          <p:cNvPr id="9" name="TextBox 8"/>
+          <p:cNvSpPr txBox="1"/>
+          <p:nvPr/>
+        </p:nvSpPr>
+        <p:spPr>
+          <a:xfrm>
+            <a:off x="548640" y="6537959"/>
+            <a:ext cx="5212080" cy="274320"/>
+          </a:xfrm>
+          <a:prstGeom prst="rect">
+            <a:avLst/>
+          </a:prstGeom>
+          <a:noFill/>
+        </p:spPr>
+        <p:txBody>
+          <a:bodyPr wrap="square" lIns="0" rIns="0">
+            <a:spAutoFit/>
+          </a:bodyPr>
+          <a:lstStyle/>
+          <a:p>
+            <a:pPr algn="ctr"/>
+            <a:r>
+              <a:rPr sz="1400" b="0">
+                <a:solidFill>
+                  <a:srgbClr val="6B7280"/>
+                </a:solidFill>
+                <a:latin typeface="Helvetica"/>
+              </a:rPr>
+              <a:t>Match: Tim</a:t>
+            </a:r>
+          </a:p>
+        </p:txBody>
+      </p:sp>
+      <p:pic>
+        <p:nvPicPr>
+          <p:cNvPr id="10" name="Picture 9" descr="06_focus@2x.png"/>
+          <p:cNvPicPr>
+            <a:picLocks noChangeAspect="1"/>
+          </p:cNvPicPr>
+          <p:nvPr/>
+        </p:nvPicPr>
+        <p:blipFill>
+          <a:blip r:embed="rId5"/>
+          <a:stretch>
+            <a:fillRect/>
+          </a:stretch>
+        </p:blipFill>
+        <p:spPr>
+          <a:xfrm>
+            <a:off x="6309360" y="4206240"/>
+            <a:ext cx="5212080" cy="2606040"/>
+          </a:xfrm>
+          <a:prstGeom prst="rect">
+            <a:avLst/>
+          </a:prstGeom>
+        </p:spPr>
+      </p:pic>
+      <p:sp>
+        <p:nvSpPr>
+          <p:cNvPr id="11" name="TextBox 10"/>
+          <p:cNvSpPr txBox="1"/>
+          <p:nvPr/>
+        </p:nvSpPr>
+        <p:spPr>
+          <a:xfrm>
+            <a:off x="6309360" y="6537959"/>
+            <a:ext cx="5212080" cy="274320"/>
+          </a:xfrm>
+          <a:prstGeom prst="rect">
+            <a:avLst/>
+          </a:prstGeom>
+          <a:noFill/>
+        </p:spPr>
+        <p:txBody>
+          <a:bodyPr wrap="square" lIns="0" rIns="0">
+            <a:spAutoFit/>
+          </a:bodyPr>
+          <a:lstStyle/>
+          <a:p>
+            <a:pPr algn="ctr"/>
+            <a:r>
+              <a:rPr sz="1400" b="0">
+                <a:solidFill>
+                  <a:srgbClr val="6B7280"/>
+                </a:solidFill>
+                <a:latin typeface="Helvetica"/>
+              </a:rPr>
+              <a:t>Focus mode</a:t>
             </a:r>
           </a:p>
         </p:txBody>
@@ -4433,7 +4679,7 @@
         </p:nvSpPr>
         <p:spPr>
           <a:xfrm>
-            <a:off x="640080" y="548640"/>
+            <a:off x="640080" y="274320"/>
             <a:ext cx="10972800" cy="457200"/>
           </a:xfrm>
           <a:prstGeom prst="rect">
@@ -4455,134 +4701,35 @@
                 </a:solidFill>
                 <a:latin typeface="Helvetica"/>
               </a:rPr>
-              <a:t>PRIVACY, BY DESIGN</a:t>
-            </a:r>
-          </a:p>
-        </p:txBody>
-      </p:sp>
-      <p:sp>
-        <p:nvSpPr>
-          <p:cNvPr id="3" name="TextBox 2"/>
-          <p:cNvSpPr txBox="1"/>
+              <a:t>HOW IT WORKS</a:t>
+            </a:r>
+          </a:p>
+        </p:txBody>
+      </p:sp>
+      <p:pic>
+        <p:nvPicPr>
+          <p:cNvPr id="3" name="Picture 2" descr="flow_diagram.png"/>
+          <p:cNvPicPr>
+            <a:picLocks noChangeAspect="1"/>
+          </p:cNvPicPr>
           <p:nvPr/>
-        </p:nvSpPr>
-        <p:spPr>
-          <a:xfrm>
-            <a:off x="640080" y="1097280"/>
-            <a:ext cx="10972800" cy="1280160"/>
+        </p:nvPicPr>
+        <p:blipFill>
+          <a:blip r:embed="rId2"/>
+          <a:stretch>
+            <a:fillRect/>
+          </a:stretch>
+        </p:blipFill>
+        <p:spPr>
+          <a:xfrm>
+            <a:off x="457200" y="822960"/>
+            <a:ext cx="11247120" cy="4920615"/>
           </a:xfrm>
           <a:prstGeom prst="rect">
             <a:avLst/>
           </a:prstGeom>
-          <a:noFill/>
-        </p:spPr>
-        <p:txBody>
-          <a:bodyPr wrap="square" lIns="0" rIns="0">
-            <a:spAutoFit/>
-          </a:bodyPr>
-          <a:lstStyle/>
-          <a:p>
-            <a:pPr algn="l"/>
-            <a:r>
-              <a:rPr sz="4400" b="1">
-                <a:solidFill>
-                  <a:srgbClr val="0E0E0E"/>
-                </a:solidFill>
-                <a:latin typeface="Helvetica"/>
-              </a:rPr>
-              <a:t>Cue only remembers people
-you chose to remember.</a:t>
-            </a:r>
-          </a:p>
-        </p:txBody>
-      </p:sp>
-      <p:sp>
-        <p:nvSpPr>
-          <p:cNvPr id="4" name="TextBox 3"/>
-          <p:cNvSpPr txBox="1"/>
-          <p:nvPr/>
-        </p:nvSpPr>
-        <p:spPr>
-          <a:xfrm>
-            <a:off x="640080" y="3931920"/>
-            <a:ext cx="10972800" cy="2743200"/>
-          </a:xfrm>
-          <a:prstGeom prst="rect">
-            <a:avLst/>
-          </a:prstGeom>
-          <a:noFill/>
-        </p:spPr>
-        <p:txBody>
-          <a:bodyPr wrap="square">
-            <a:spAutoFit/>
-          </a:bodyPr>
-          <a:lstStyle/>
-          <a:p>
-            <a:pPr algn="l">
-              <a:spcAft>
-                <a:spcPts val="800"/>
-              </a:spcAft>
-            </a:pPr>
-            <a:r>
-              <a:rPr sz="2000">
-                <a:solidFill>
-                  <a:srgbClr val="0E0E0E"/>
-                </a:solidFill>
-                <a:latin typeface="Helvetica"/>
-              </a:rPr>
-              <a:t>—  Explicit enrollment — no row is written without a temple tap</a:t>
-            </a:r>
-          </a:p>
-          <a:p>
-            <a:pPr algn="l">
-              <a:spcAft>
-                <a:spcPts val="800"/>
-              </a:spcAft>
-            </a:pPr>
-            <a:r>
-              <a:rPr sz="2000">
-                <a:solidFill>
-                  <a:srgbClr val="0E0E0E"/>
-                </a:solidFill>
-                <a:latin typeface="Helvetica"/>
-              </a:rPr>
-              <a:t>—  Local-first — ~/.cue/people.db lives on your phone. One-tap delete.</a:t>
-            </a:r>
-          </a:p>
-          <a:p>
-            <a:pPr algn="l">
-              <a:spcAft>
-                <a:spcPts val="800"/>
-              </a:spcAft>
-            </a:pPr>
-            <a:r>
-              <a:rPr sz="2000">
-                <a:solidFill>
-                  <a:srgbClr val="0E0E0E"/>
-                </a:solidFill>
-                <a:latin typeface="Helvetica"/>
-              </a:rPr>
-              <a:t>—  Cameraless by physics — the G2 has no lens. No face database exists.</a:t>
-            </a:r>
-          </a:p>
-          <a:p>
-            <a:pPr algn="l">
-              <a:spcAft>
-                <a:spcPts val="800"/>
-              </a:spcAft>
-            </a:pPr>
-            <a:r>
-              <a:rPr sz="2000">
-                <a:solidFill>
-                  <a:srgbClr val="0E0E0E"/>
-                </a:solidFill>
-                <a:latin typeface="Helvetica"/>
-              </a:rPr>
-              <a:t>—  No network on the critical path. Claude used only for optional summaries.</a:t>
-            </a:r>
-          </a:p>
-        </p:txBody>
-      </p:sp>
+        </p:spPr>
+      </p:pic>
     </p:spTree>
   </p:cSld>
   <p:clrMapOvr>
@@ -4592,6 +4739,126 @@
 </file>
 
 <file path=ppt/slides/slide8.xml><?xml version="1.0" encoding="utf-8"?>
+<p:sld xmlns:a="http://schemas.openxmlformats.org/drawingml/2006/main" xmlns:p="http://schemas.openxmlformats.org/presentationml/2006/main" xmlns:r="http://schemas.openxmlformats.org/officeDocument/2006/relationships">
+  <p:cSld>
+    <p:bg>
+      <p:bgPr>
+        <a:solidFill>
+          <a:srgbClr val="111827"/>
+        </a:solidFill>
+        <a:effectLst/>
+      </p:bgPr>
+    </p:bg>
+    <p:spTree>
+      <p:nvGrpSpPr>
+        <p:cNvPr id="1" name=""/>
+        <p:cNvGrpSpPr/>
+        <p:nvPr/>
+      </p:nvGrpSpPr>
+      <p:grpSpPr/>
+      <p:sp>
+        <p:nvSpPr>
+          <p:cNvPr id="2" name="TextBox 1"/>
+          <p:cNvSpPr txBox="1"/>
+          <p:nvPr/>
+        </p:nvSpPr>
+        <p:spPr>
+          <a:xfrm>
+            <a:off x="640080" y="365760"/>
+            <a:ext cx="10972800" cy="457200"/>
+          </a:xfrm>
+          <a:prstGeom prst="rect">
+            <a:avLst/>
+          </a:prstGeom>
+          <a:noFill/>
+        </p:spPr>
+        <p:txBody>
+          <a:bodyPr wrap="square" lIns="0" rIns="0">
+            <a:spAutoFit/>
+          </a:bodyPr>
+          <a:lstStyle/>
+          <a:p>
+            <a:pPr algn="l"/>
+            <a:r>
+              <a:rPr sz="1200" b="1">
+                <a:solidFill>
+                  <a:srgbClr val="00B86F"/>
+                </a:solidFill>
+                <a:latin typeface="Helvetica"/>
+              </a:rPr>
+              <a:t>WHAT THE OPERATOR SEES</a:t>
+            </a:r>
+          </a:p>
+        </p:txBody>
+      </p:sp>
+      <p:sp>
+        <p:nvSpPr>
+          <p:cNvPr id="3" name="TextBox 2"/>
+          <p:cNvSpPr txBox="1"/>
+          <p:nvPr/>
+        </p:nvSpPr>
+        <p:spPr>
+          <a:xfrm>
+            <a:off x="640080" y="822960"/>
+            <a:ext cx="10972800" cy="548640"/>
+          </a:xfrm>
+          <a:prstGeom prst="rect">
+            <a:avLst/>
+          </a:prstGeom>
+          <a:noFill/>
+        </p:spPr>
+        <p:txBody>
+          <a:bodyPr wrap="square" lIns="0" rIns="0">
+            <a:spAutoFit/>
+          </a:bodyPr>
+          <a:lstStyle/>
+          <a:p>
+            <a:pPr algn="l"/>
+            <a:r>
+              <a:rPr sz="2000" b="0">
+                <a:solidFill>
+                  <a:srgbClr val="EEEEEE"/>
+                </a:solidFill>
+                <a:latin typeface="Helvetica"/>
+              </a:rPr>
+              <a:t>Terminal A — live recognition log on stage</a:t>
+            </a:r>
+          </a:p>
+        </p:txBody>
+      </p:sp>
+      <p:pic>
+        <p:nvPicPr>
+          <p:cNvPr id="4" name="Picture 3" descr="07_terminal_log.png"/>
+          <p:cNvPicPr>
+            <a:picLocks noChangeAspect="1"/>
+          </p:cNvPicPr>
+          <p:nvPr/>
+        </p:nvPicPr>
+        <p:blipFill>
+          <a:blip r:embed="rId2"/>
+          <a:stretch>
+            <a:fillRect/>
+          </a:stretch>
+        </p:blipFill>
+        <p:spPr>
+          <a:xfrm>
+            <a:off x="1645920" y="1737360"/>
+            <a:ext cx="8869680" cy="4434840"/>
+          </a:xfrm>
+          <a:prstGeom prst="rect">
+            <a:avLst/>
+          </a:prstGeom>
+        </p:spPr>
+      </p:pic>
+    </p:spTree>
+  </p:cSld>
+  <p:clrMapOvr>
+    <a:masterClrMapping/>
+  </p:clrMapOvr>
+</p:sld>
+</file>
+
+<file path=ppt/slides/slide9.xml><?xml version="1.0" encoding="utf-8"?>
 <p:sld xmlns:a="http://schemas.openxmlformats.org/drawingml/2006/main" xmlns:p="http://schemas.openxmlformats.org/presentationml/2006/main" xmlns:r="http://schemas.openxmlformats.org/officeDocument/2006/relationships">
   <p:cSld>
     <p:bg>
@@ -4639,7 +4906,7 @@
                 </a:solidFill>
                 <a:latin typeface="Helvetica"/>
               </a:rPr>
-              <a:t>WHY PEOPLE'S CHOICE</a:t>
+              <a:t>PRIVACY, BY DESIGN</a:t>
             </a:r>
           </a:p>
         </p:txBody>
@@ -4653,7 +4920,7 @@
         <p:spPr>
           <a:xfrm>
             <a:off x="640080" y="1097280"/>
-            <a:ext cx="10972800" cy="914400"/>
+            <a:ext cx="10972800" cy="1280160"/>
           </a:xfrm>
           <a:prstGeom prst="rect">
             <a:avLst/>
@@ -4674,7 +4941,8 @@
                 </a:solidFill>
                 <a:latin typeface="Helvetica"/>
               </a:rPr>
-              <a:t>Cue is the room.</a:t>
+              <a:t>Cue only remembers people
+you chose to remember.</a:t>
             </a:r>
           </a:p>
         </p:txBody>
@@ -4687,8 +4955,8 @@
         </p:nvSpPr>
         <p:spPr>
           <a:xfrm>
-            <a:off x="640080" y="2560320"/>
-            <a:ext cx="10972800" cy="3657600"/>
+            <a:off x="640080" y="3931920"/>
+            <a:ext cx="10972800" cy="2743200"/>
           </a:xfrm>
           <a:prstGeom prst="rect">
             <a:avLst/>
@@ -4713,7 +4981,7 @@
                 </a:solidFill>
                 <a:latin typeface="Helvetica"/>
               </a:rPr>
-              <a:t>—  Every judge forgot someone's name this week. Felt the micro-panic.</a:t>
+              <a:t>—  Explicit enrollment — no row is written without a temple tap</a:t>
             </a:r>
           </a:p>
           <a:p>
@@ -4729,7 +4997,7 @@
                 </a:solidFill>
                 <a:latin typeface="Helvetica"/>
               </a:rPr>
-              <a:t>—  Every audience member is re-living it as pre-seeded teammates walk up.</a:t>
+              <a:t>—  Local-first — ~/.cue/people.db lives on your phone. One-tap delete.</a:t>
             </a:r>
           </a:p>
           <a:p>
@@ -4745,7 +5013,7 @@
                 </a:solidFill>
                 <a:latin typeface="Helvetica"/>
               </a:rPr>
-              <a:t>—  Tagline repeats itself: "Meta Ray-Bans remember faces. Cue remembers people."</a:t>
+              <a:t>—  Cameraless by physics — the G2 has no lens. No face database exists.</a:t>
             </a:r>
           </a:p>
           <a:p>
@@ -4761,174 +5029,7 @@
                 </a:solidFill>
                 <a:latin typeface="Helvetica"/>
               </a:rPr>
-              <a:t>—  "Quiet Tech" rendered as product. Best Brand Fit fallback.</a:t>
-            </a:r>
-          </a:p>
-        </p:txBody>
-      </p:sp>
-    </p:spTree>
-  </p:cSld>
-  <p:clrMapOvr>
-    <a:masterClrMapping/>
-  </p:clrMapOvr>
-</p:sld>
-</file>
-
-<file path=ppt/slides/slide9.xml><?xml version="1.0" encoding="utf-8"?>
-<p:sld xmlns:a="http://schemas.openxmlformats.org/drawingml/2006/main" xmlns:p="http://schemas.openxmlformats.org/presentationml/2006/main" xmlns:r="http://schemas.openxmlformats.org/officeDocument/2006/relationships">
-  <p:cSld>
-    <p:bg>
-      <p:bgPr>
-        <a:solidFill>
-          <a:srgbClr val="111827"/>
-        </a:solidFill>
-        <a:effectLst/>
-      </p:bgPr>
-    </p:bg>
-    <p:spTree>
-      <p:nvGrpSpPr>
-        <p:cNvPr id="1" name=""/>
-        <p:cNvGrpSpPr/>
-        <p:nvPr/>
-      </p:nvGrpSpPr>
-      <p:grpSpPr/>
-      <p:sp>
-        <p:nvSpPr>
-          <p:cNvPr id="2" name="TextBox 1"/>
-          <p:cNvSpPr txBox="1"/>
-          <p:nvPr/>
-        </p:nvSpPr>
-        <p:spPr>
-          <a:xfrm>
-            <a:off x="640080" y="1371600"/>
-            <a:ext cx="10972800" cy="1097280"/>
-          </a:xfrm>
-          <a:prstGeom prst="rect">
-            <a:avLst/>
-          </a:prstGeom>
-          <a:noFill/>
-        </p:spPr>
-        <p:txBody>
-          <a:bodyPr wrap="square" lIns="0" rIns="0">
-            <a:spAutoFit/>
-          </a:bodyPr>
-          <a:lstStyle/>
-          <a:p>
-            <a:pPr algn="ctr"/>
-            <a:r>
-              <a:rPr sz="5600" b="1">
-                <a:solidFill>
-                  <a:srgbClr val="FFFFFF"/>
-                </a:solidFill>
-                <a:latin typeface="Helvetica"/>
-              </a:rPr>
-              <a:t>Faces are data.</a:t>
-            </a:r>
-          </a:p>
-        </p:txBody>
-      </p:sp>
-      <p:sp>
-        <p:nvSpPr>
-          <p:cNvPr id="3" name="TextBox 2"/>
-          <p:cNvSpPr txBox="1"/>
-          <p:nvPr/>
-        </p:nvSpPr>
-        <p:spPr>
-          <a:xfrm>
-            <a:off x="640080" y="2560320"/>
-            <a:ext cx="10972800" cy="1097280"/>
-          </a:xfrm>
-          <a:prstGeom prst="rect">
-            <a:avLst/>
-          </a:prstGeom>
-          <a:noFill/>
-        </p:spPr>
-        <p:txBody>
-          <a:bodyPr wrap="square" lIns="0" rIns="0">
-            <a:spAutoFit/>
-          </a:bodyPr>
-          <a:lstStyle/>
-          <a:p>
-            <a:pPr algn="ctr"/>
-            <a:r>
-              <a:rPr sz="5600" b="1">
-                <a:solidFill>
-                  <a:srgbClr val="00B86F"/>
-                </a:solidFill>
-                <a:latin typeface="Helvetica"/>
-              </a:rPr>
-              <a:t>People are memory.</a:t>
-            </a:r>
-          </a:p>
-        </p:txBody>
-      </p:sp>
-      <p:sp>
-        <p:nvSpPr>
-          <p:cNvPr id="4" name="TextBox 3"/>
-          <p:cNvSpPr txBox="1"/>
-          <p:nvPr/>
-        </p:nvSpPr>
-        <p:spPr>
-          <a:xfrm>
-            <a:off x="640080" y="4206240"/>
-            <a:ext cx="10972800" cy="731520"/>
-          </a:xfrm>
-          <a:prstGeom prst="rect">
-            <a:avLst/>
-          </a:prstGeom>
-          <a:noFill/>
-        </p:spPr>
-        <p:txBody>
-          <a:bodyPr wrap="square" lIns="0" rIns="0">
-            <a:spAutoFit/>
-          </a:bodyPr>
-          <a:lstStyle/>
-          <a:p>
-            <a:pPr algn="ctr"/>
-            <a:r>
-              <a:rPr sz="2200" b="0">
-                <a:solidFill>
-                  <a:srgbClr val="DDDDDD"/>
-                </a:solidFill>
-                <a:latin typeface="Helvetica"/>
-              </a:rPr>
-              <a:t>G2 is the first wearable quiet enough
-to hold the second one.</a:t>
-            </a:r>
-          </a:p>
-        </p:txBody>
-      </p:sp>
-      <p:sp>
-        <p:nvSpPr>
-          <p:cNvPr id="5" name="TextBox 4"/>
-          <p:cNvSpPr txBox="1"/>
-          <p:nvPr/>
-        </p:nvSpPr>
-        <p:spPr>
-          <a:xfrm>
-            <a:off x="640080" y="6035040"/>
-            <a:ext cx="10972800" cy="365760"/>
-          </a:xfrm>
-          <a:prstGeom prst="rect">
-            <a:avLst/>
-          </a:prstGeom>
-          <a:noFill/>
-        </p:spPr>
-        <p:txBody>
-          <a:bodyPr wrap="square" lIns="0" rIns="0">
-            <a:spAutoFit/>
-          </a:bodyPr>
-          <a:lstStyle/>
-          <a:p>
-            <a:pPr algn="ctr"/>
-            <a:r>
-              <a:rPr sz="1400" b="0">
-                <a:solidFill>
-                  <a:srgbClr val="6B7280"/>
-                </a:solidFill>
-                <a:latin typeface="Helvetica"/>
-              </a:rPr>
-              <a:t>Thank you.  ·  github.com/abhishekj720/Cue-evenRealitiesG2</a:t>
+              <a:t>—  No network on the critical path. Claude used only for optional summaries.</a:t>
             </a:r>
           </a:p>
         </p:txBody>

</xml_diff>

<commit_message>
pitch: add What's Next slide; tone-fix slide 10 (resonates, not people's choice)
</commit_message>
<xml_diff>
--- a/docs/Cue-Pitch.pptx
+++ b/docs/Cue-Pitch.pptx
@@ -16,6 +16,7 @@
     <p:sldId id="264" r:id="rId15"/>
     <p:sldId id="265" r:id="rId16"/>
     <p:sldId id="266" r:id="rId17"/>
+    <p:sldId id="267" r:id="rId18"/>
   </p:sldIdLst>
   <p:sldSz cx="12191695" cy="6858000" type="screen4x3"/>
   <p:notesSz cx="6858000" cy="9144000"/>
@@ -3267,7 +3268,7 @@
                 </a:solidFill>
                 <a:latin typeface="Helvetica"/>
               </a:rPr>
-              <a:t>WHY PEOPLE'S CHOICE</a:t>
+              <a:t>WHY THIS RESONATES</a:t>
             </a:r>
           </a:p>
         </p:txBody>
@@ -3335,13 +3336,13 @@
               </a:spcAft>
             </a:pPr>
             <a:r>
-              <a:rPr sz="2000">
+              <a:rPr sz="2200">
                 <a:solidFill>
                   <a:srgbClr val="0E0E0E"/>
                 </a:solidFill>
                 <a:latin typeface="Helvetica"/>
               </a:rPr>
-              <a:t>—  Every judge forgot someone's name this week. Felt the micro-panic.</a:t>
+              <a:t>—  Everyone here forgot someone's name this week.</a:t>
             </a:r>
           </a:p>
           <a:p>
@@ -3351,13 +3352,13 @@
               </a:spcAft>
             </a:pPr>
             <a:r>
-              <a:rPr sz="2000">
+              <a:rPr sz="2200">
                 <a:solidFill>
                   <a:srgbClr val="0E0E0E"/>
                 </a:solidFill>
                 <a:latin typeface="Helvetica"/>
               </a:rPr>
-              <a:t>—  Every audience member is re-living it as pre-seeded teammates walk up.</a:t>
+              <a:t>—  You walked into 40 intros today. You'll forget 34.</a:t>
             </a:r>
           </a:p>
           <a:p>
@@ -3367,13 +3368,13 @@
               </a:spcAft>
             </a:pPr>
             <a:r>
-              <a:rPr sz="2000">
+              <a:rPr sz="2200">
                 <a:solidFill>
                   <a:srgbClr val="0E0E0E"/>
                 </a:solidFill>
                 <a:latin typeface="Helvetica"/>
               </a:rPr>
-              <a:t>—  Tagline repeats itself: "Meta Ray-Bans remember faces. Cue remembers people."</a:t>
+              <a:t>—  Meta tried cameras — they get you thrown out of the room.</a:t>
             </a:r>
           </a:p>
           <a:p>
@@ -3383,13 +3384,13 @@
               </a:spcAft>
             </a:pPr>
             <a:r>
-              <a:rPr sz="2000">
+              <a:rPr sz="2200">
                 <a:solidFill>
                   <a:srgbClr val="0E0E0E"/>
                 </a:solidFill>
                 <a:latin typeface="Helvetica"/>
               </a:rPr>
-              <a:t>—  "Quiet Tech" rendered as product. Best Brand Fit fallback.</a:t>
+              <a:t>—  G2 stays in. Cue is Quiet Tech rendered as product.</a:t>
             </a:r>
           </a:p>
         </p:txBody>
@@ -3403,6 +3404,591 @@
 </file>
 
 <file path=ppt/slides/slide11.xml><?xml version="1.0" encoding="utf-8"?>
+<p:sld xmlns:a="http://schemas.openxmlformats.org/drawingml/2006/main" xmlns:p="http://schemas.openxmlformats.org/presentationml/2006/main" xmlns:r="http://schemas.openxmlformats.org/officeDocument/2006/relationships">
+  <p:cSld>
+    <p:bg>
+      <p:bgPr>
+        <a:solidFill>
+          <a:srgbClr val="FAFAFA"/>
+        </a:solidFill>
+        <a:effectLst/>
+      </p:bgPr>
+    </p:bg>
+    <p:spTree>
+      <p:nvGrpSpPr>
+        <p:cNvPr id="1" name=""/>
+        <p:cNvGrpSpPr/>
+        <p:nvPr/>
+      </p:nvGrpSpPr>
+      <p:grpSpPr/>
+      <p:sp>
+        <p:nvSpPr>
+          <p:cNvPr id="2" name="TextBox 1"/>
+          <p:cNvSpPr txBox="1"/>
+          <p:nvPr/>
+        </p:nvSpPr>
+        <p:spPr>
+          <a:xfrm>
+            <a:off x="640080" y="548640"/>
+            <a:ext cx="10972800" cy="457200"/>
+          </a:xfrm>
+          <a:prstGeom prst="rect">
+            <a:avLst/>
+          </a:prstGeom>
+          <a:noFill/>
+        </p:spPr>
+        <p:txBody>
+          <a:bodyPr wrap="square" lIns="0" rIns="0">
+            <a:spAutoFit/>
+          </a:bodyPr>
+          <a:lstStyle/>
+          <a:p>
+            <a:pPr algn="l"/>
+            <a:r>
+              <a:rPr sz="1200" b="1">
+                <a:solidFill>
+                  <a:srgbClr val="00B86F"/>
+                </a:solidFill>
+                <a:latin typeface="Helvetica"/>
+              </a:rPr>
+              <a:t>WHAT'S NEXT</a:t>
+            </a:r>
+          </a:p>
+        </p:txBody>
+      </p:sp>
+      <p:sp>
+        <p:nvSpPr>
+          <p:cNvPr id="3" name="TextBox 2"/>
+          <p:cNvSpPr txBox="1"/>
+          <p:nvPr/>
+        </p:nvSpPr>
+        <p:spPr>
+          <a:xfrm>
+            <a:off x="640080" y="1005840"/>
+            <a:ext cx="10972800" cy="914400"/>
+          </a:xfrm>
+          <a:prstGeom prst="rect">
+            <a:avLst/>
+          </a:prstGeom>
+          <a:noFill/>
+        </p:spPr>
+        <p:txBody>
+          <a:bodyPr wrap="square" lIns="0" rIns="0">
+            <a:spAutoFit/>
+          </a:bodyPr>
+          <a:lstStyle/>
+          <a:p>
+            <a:pPr algn="l"/>
+            <a:r>
+              <a:rPr sz="3600" b="1">
+                <a:solidFill>
+                  <a:srgbClr val="0E0E0E"/>
+                </a:solidFill>
+                <a:latin typeface="Helvetica"/>
+              </a:rPr>
+              <a:t>From hackathon to daily wear.</a:t>
+            </a:r>
+          </a:p>
+        </p:txBody>
+      </p:sp>
+      <p:sp>
+        <p:nvSpPr>
+          <p:cNvPr id="4" name="Rectangle 3"/>
+          <p:cNvSpPr/>
+          <p:nvPr/>
+        </p:nvSpPr>
+        <p:spPr>
+          <a:xfrm>
+            <a:off x="457200" y="2011680"/>
+            <a:ext cx="5394960" cy="1280160"/>
+          </a:xfrm>
+          <a:prstGeom prst="rect">
+            <a:avLst/>
+          </a:prstGeom>
+          <a:solidFill>
+            <a:srgbClr val="FFFFFF"/>
+          </a:solidFill>
+          <a:ln w="19050">
+            <a:solidFill>
+              <a:srgbClr val="00B86F"/>
+            </a:solidFill>
+          </a:ln>
+        </p:spPr>
+        <p:style>
+          <a:lnRef idx="1">
+            <a:schemeClr val="accent1"/>
+          </a:lnRef>
+          <a:fillRef idx="3">
+            <a:schemeClr val="accent1"/>
+          </a:fillRef>
+          <a:effectRef idx="2">
+            <a:schemeClr val="accent1"/>
+          </a:effectRef>
+          <a:fontRef idx="minor">
+            <a:schemeClr val="lt1"/>
+          </a:fontRef>
+        </p:style>
+        <p:txBody>
+          <a:bodyPr rtlCol="0" anchor="ctr" wrap="square" lIns="182880" rIns="182880" tIns="109728"/>
+          <a:lstStyle/>
+          <a:p>
+            <a:pPr algn="ctr"/>
+            <a:r>
+              <a:rPr sz="1800" b="1">
+                <a:solidFill>
+                  <a:srgbClr val="0E0E0E"/>
+                </a:solidFill>
+                <a:latin typeface="Helvetica"/>
+              </a:rPr>
+              <a:t>Speaker diarization</a:t>
+            </a:r>
+          </a:p>
+          <a:p>
+            <a:r>
+              <a:rPr sz="1300">
+                <a:solidFill>
+                  <a:srgbClr val="6B7280"/>
+                </a:solidFill>
+                <a:latin typeface="Helvetica"/>
+              </a:rPr>
+              <a:t>Match multiple voices in group</a:t>
+            </a:r>
+          </a:p>
+          <a:p>
+            <a:r>
+              <a:rPr sz="1300">
+                <a:solidFill>
+                  <a:srgbClr val="6B7280"/>
+                </a:solidFill>
+                <a:latin typeface="Helvetica"/>
+              </a:rPr>
+              <a:t>conversations, not just 1:1.</a:t>
+            </a:r>
+          </a:p>
+        </p:txBody>
+      </p:sp>
+      <p:sp>
+        <p:nvSpPr>
+          <p:cNvPr id="5" name="Rectangle 4"/>
+          <p:cNvSpPr/>
+          <p:nvPr/>
+        </p:nvSpPr>
+        <p:spPr>
+          <a:xfrm>
+            <a:off x="457200" y="3474720"/>
+            <a:ext cx="5394960" cy="1280160"/>
+          </a:xfrm>
+          <a:prstGeom prst="rect">
+            <a:avLst/>
+          </a:prstGeom>
+          <a:solidFill>
+            <a:srgbClr val="FFFFFF"/>
+          </a:solidFill>
+          <a:ln w="19050">
+            <a:solidFill>
+              <a:srgbClr val="00B86F"/>
+            </a:solidFill>
+          </a:ln>
+        </p:spPr>
+        <p:style>
+          <a:lnRef idx="1">
+            <a:schemeClr val="accent1"/>
+          </a:lnRef>
+          <a:fillRef idx="3">
+            <a:schemeClr val="accent1"/>
+          </a:fillRef>
+          <a:effectRef idx="2">
+            <a:schemeClr val="accent1"/>
+          </a:effectRef>
+          <a:fontRef idx="minor">
+            <a:schemeClr val="lt1"/>
+          </a:fontRef>
+        </p:style>
+        <p:txBody>
+          <a:bodyPr rtlCol="0" anchor="ctr" wrap="square" lIns="182880" rIns="182880" tIns="109728"/>
+          <a:lstStyle/>
+          <a:p>
+            <a:pPr algn="ctr"/>
+            <a:r>
+              <a:rPr sz="1800" b="1">
+                <a:solidFill>
+                  <a:srgbClr val="0E0E0E"/>
+                </a:solidFill>
+                <a:latin typeface="Helvetica"/>
+              </a:rPr>
+              <a:t>Proactive recall</a:t>
+            </a:r>
+          </a:p>
+          <a:p>
+            <a:r>
+              <a:rPr sz="1300">
+                <a:solidFill>
+                  <a:srgbClr val="6B7280"/>
+                </a:solidFill>
+                <a:latin typeface="Helvetica"/>
+              </a:rPr>
+              <a:t>"You promised Priya a beta</a:t>
+            </a:r>
+          </a:p>
+          <a:p>
+            <a:r>
+              <a:rPr sz="1300">
+                <a:solidFill>
+                  <a:srgbClr val="6B7280"/>
+                </a:solidFill>
+                <a:latin typeface="Helvetica"/>
+              </a:rPr>
+              <a:t>invite 21 days ago." — surfaced</a:t>
+            </a:r>
+          </a:p>
+          <a:p>
+            <a:r>
+              <a:rPr sz="1300">
+                <a:solidFill>
+                  <a:srgbClr val="6B7280"/>
+                </a:solidFill>
+                <a:latin typeface="Helvetica"/>
+              </a:rPr>
+              <a:t>when her voice is detected.</a:t>
+            </a:r>
+          </a:p>
+        </p:txBody>
+      </p:sp>
+      <p:sp>
+        <p:nvSpPr>
+          <p:cNvPr id="6" name="Rectangle 5"/>
+          <p:cNvSpPr/>
+          <p:nvPr/>
+        </p:nvSpPr>
+        <p:spPr>
+          <a:xfrm>
+            <a:off x="457200" y="4937760"/>
+            <a:ext cx="5394960" cy="1280160"/>
+          </a:xfrm>
+          <a:prstGeom prst="rect">
+            <a:avLst/>
+          </a:prstGeom>
+          <a:solidFill>
+            <a:srgbClr val="FFFFFF"/>
+          </a:solidFill>
+          <a:ln w="19050">
+            <a:solidFill>
+              <a:srgbClr val="00B86F"/>
+            </a:solidFill>
+          </a:ln>
+        </p:spPr>
+        <p:style>
+          <a:lnRef idx="1">
+            <a:schemeClr val="accent1"/>
+          </a:lnRef>
+          <a:fillRef idx="3">
+            <a:schemeClr val="accent1"/>
+          </a:fillRef>
+          <a:effectRef idx="2">
+            <a:schemeClr val="accent1"/>
+          </a:effectRef>
+          <a:fontRef idx="minor">
+            <a:schemeClr val="lt1"/>
+          </a:fontRef>
+        </p:style>
+        <p:txBody>
+          <a:bodyPr rtlCol="0" anchor="ctr" wrap="square" lIns="182880" rIns="182880" tIns="109728"/>
+          <a:lstStyle/>
+          <a:p>
+            <a:pPr algn="ctr"/>
+            <a:r>
+              <a:rPr sz="1800" b="1">
+                <a:solidFill>
+                  <a:srgbClr val="0E0E0E"/>
+                </a:solidFill>
+                <a:latin typeface="Helvetica"/>
+              </a:rPr>
+              <a:t>Calendar hydration</a:t>
+            </a:r>
+          </a:p>
+          <a:p>
+            <a:r>
+              <a:rPr sz="1300">
+                <a:solidFill>
+                  <a:srgbClr val="6B7280"/>
+                </a:solidFill>
+                <a:latin typeface="Helvetica"/>
+              </a:rPr>
+              <a:t>Pull last meeting notes for the</a:t>
+            </a:r>
+          </a:p>
+          <a:p>
+            <a:r>
+              <a:rPr sz="1300">
+                <a:solidFill>
+                  <a:srgbClr val="6B7280"/>
+                </a:solidFill>
+                <a:latin typeface="Helvetica"/>
+              </a:rPr>
+              <a:t>matched person from your cal.</a:t>
+            </a:r>
+          </a:p>
+        </p:txBody>
+      </p:sp>
+      <p:sp>
+        <p:nvSpPr>
+          <p:cNvPr id="7" name="Rectangle 6"/>
+          <p:cNvSpPr/>
+          <p:nvPr/>
+        </p:nvSpPr>
+        <p:spPr>
+          <a:xfrm>
+            <a:off x="6309360" y="2011680"/>
+            <a:ext cx="5394960" cy="1280160"/>
+          </a:xfrm>
+          <a:prstGeom prst="rect">
+            <a:avLst/>
+          </a:prstGeom>
+          <a:solidFill>
+            <a:srgbClr val="FFFFFF"/>
+          </a:solidFill>
+          <a:ln w="19050">
+            <a:solidFill>
+              <a:srgbClr val="00B86F"/>
+            </a:solidFill>
+          </a:ln>
+        </p:spPr>
+        <p:style>
+          <a:lnRef idx="1">
+            <a:schemeClr val="accent1"/>
+          </a:lnRef>
+          <a:fillRef idx="3">
+            <a:schemeClr val="accent1"/>
+          </a:fillRef>
+          <a:effectRef idx="2">
+            <a:schemeClr val="accent1"/>
+          </a:effectRef>
+          <a:fontRef idx="minor">
+            <a:schemeClr val="lt1"/>
+          </a:fontRef>
+        </p:style>
+        <p:txBody>
+          <a:bodyPr rtlCol="0" anchor="ctr" wrap="square" lIns="182880" rIns="182880" tIns="109728"/>
+          <a:lstStyle/>
+          <a:p>
+            <a:pPr algn="ctr"/>
+            <a:r>
+              <a:rPr sz="1800" b="1">
+                <a:solidFill>
+                  <a:srgbClr val="0E0E0E"/>
+                </a:solidFill>
+                <a:latin typeface="Helvetica"/>
+              </a:rPr>
+              <a:t>Two-way consent</a:t>
+            </a:r>
+          </a:p>
+          <a:p>
+            <a:r>
+              <a:rPr sz="1300">
+                <a:solidFill>
+                  <a:srgbClr val="6B7280"/>
+                </a:solidFill>
+                <a:latin typeface="Helvetica"/>
+              </a:rPr>
+              <a:t>Two G2 wearers enroll each</a:t>
+            </a:r>
+          </a:p>
+          <a:p>
+            <a:r>
+              <a:rPr sz="1300">
+                <a:solidFill>
+                  <a:srgbClr val="6B7280"/>
+                </a:solidFill>
+                <a:latin typeface="Helvetica"/>
+              </a:rPr>
+              <a:t>other in one tap. Standardized</a:t>
+            </a:r>
+          </a:p>
+          <a:p>
+            <a:r>
+              <a:rPr sz="1300">
+                <a:solidFill>
+                  <a:srgbClr val="6B7280"/>
+                </a:solidFill>
+                <a:latin typeface="Helvetica"/>
+              </a:rPr>
+              <a:t>consent handshake.</a:t>
+            </a:r>
+          </a:p>
+        </p:txBody>
+      </p:sp>
+      <p:sp>
+        <p:nvSpPr>
+          <p:cNvPr id="8" name="Rectangle 7"/>
+          <p:cNvSpPr/>
+          <p:nvPr/>
+        </p:nvSpPr>
+        <p:spPr>
+          <a:xfrm>
+            <a:off x="6309360" y="3474720"/>
+            <a:ext cx="5394960" cy="1280160"/>
+          </a:xfrm>
+          <a:prstGeom prst="rect">
+            <a:avLst/>
+          </a:prstGeom>
+          <a:solidFill>
+            <a:srgbClr val="FFFFFF"/>
+          </a:solidFill>
+          <a:ln w="19050">
+            <a:solidFill>
+              <a:srgbClr val="00B86F"/>
+            </a:solidFill>
+          </a:ln>
+        </p:spPr>
+        <p:style>
+          <a:lnRef idx="1">
+            <a:schemeClr val="accent1"/>
+          </a:lnRef>
+          <a:fillRef idx="3">
+            <a:schemeClr val="accent1"/>
+          </a:fillRef>
+          <a:effectRef idx="2">
+            <a:schemeClr val="accent1"/>
+          </a:effectRef>
+          <a:fontRef idx="minor">
+            <a:schemeClr val="lt1"/>
+          </a:fontRef>
+        </p:style>
+        <p:txBody>
+          <a:bodyPr rtlCol="0" anchor="ctr" wrap="square" lIns="182880" rIns="182880" tIns="109728"/>
+          <a:lstStyle/>
+          <a:p>
+            <a:pPr algn="ctr"/>
+            <a:r>
+              <a:rPr sz="1800" b="1">
+                <a:solidFill>
+                  <a:srgbClr val="0E0E0E"/>
+                </a:solidFill>
+                <a:latin typeface="Helvetica"/>
+              </a:rPr>
+              <a:t>CRM sync</a:t>
+            </a:r>
+          </a:p>
+          <a:p>
+            <a:r>
+              <a:rPr sz="1300">
+                <a:solidFill>
+                  <a:srgbClr val="6B7280"/>
+                </a:solidFill>
+                <a:latin typeface="Helvetica"/>
+              </a:rPr>
+              <a:t>One-way export to HubSpot or</a:t>
+            </a:r>
+          </a:p>
+          <a:p>
+            <a:r>
+              <a:rPr sz="1300">
+                <a:solidFill>
+                  <a:srgbClr val="6B7280"/>
+                </a:solidFill>
+                <a:latin typeface="Helvetica"/>
+              </a:rPr>
+              <a:t>Notion for sales workflows.</a:t>
+            </a:r>
+          </a:p>
+        </p:txBody>
+      </p:sp>
+      <p:sp>
+        <p:nvSpPr>
+          <p:cNvPr id="9" name="Rectangle 8"/>
+          <p:cNvSpPr/>
+          <p:nvPr/>
+        </p:nvSpPr>
+        <p:spPr>
+          <a:xfrm>
+            <a:off x="6309360" y="4937760"/>
+            <a:ext cx="5394960" cy="1280160"/>
+          </a:xfrm>
+          <a:prstGeom prst="rect">
+            <a:avLst/>
+          </a:prstGeom>
+          <a:solidFill>
+            <a:srgbClr val="FFFFFF"/>
+          </a:solidFill>
+          <a:ln w="19050">
+            <a:solidFill>
+              <a:srgbClr val="00B86F"/>
+            </a:solidFill>
+          </a:ln>
+        </p:spPr>
+        <p:style>
+          <a:lnRef idx="1">
+            <a:schemeClr val="accent1"/>
+          </a:lnRef>
+          <a:fillRef idx="3">
+            <a:schemeClr val="accent1"/>
+          </a:fillRef>
+          <a:effectRef idx="2">
+            <a:schemeClr val="accent1"/>
+          </a:effectRef>
+          <a:fontRef idx="minor">
+            <a:schemeClr val="lt1"/>
+          </a:fontRef>
+        </p:style>
+        <p:txBody>
+          <a:bodyPr rtlCol="0" anchor="ctr" wrap="square" lIns="182880" rIns="182880" tIns="109728"/>
+          <a:lstStyle/>
+          <a:p>
+            <a:pPr algn="ctr"/>
+            <a:r>
+              <a:rPr sz="1800" b="1">
+                <a:solidFill>
+                  <a:srgbClr val="0E0E0E"/>
+                </a:solidFill>
+                <a:latin typeface="Helvetica"/>
+              </a:rPr>
+              <a:t>On-device Claude</a:t>
+            </a:r>
+          </a:p>
+          <a:p>
+            <a:r>
+              <a:rPr sz="1300">
+                <a:solidFill>
+                  <a:srgbClr val="6B7280"/>
+                </a:solidFill>
+                <a:latin typeface="Helvetica"/>
+              </a:rPr>
+              <a:t>Brief generation runs on the</a:t>
+            </a:r>
+          </a:p>
+          <a:p>
+            <a:r>
+              <a:rPr sz="1300">
+                <a:solidFill>
+                  <a:srgbClr val="6B7280"/>
+                </a:solidFill>
+                <a:latin typeface="Helvetica"/>
+              </a:rPr>
+              <a:t>phone via on-device models —</a:t>
+            </a:r>
+          </a:p>
+          <a:p>
+            <a:r>
+              <a:rPr sz="1300">
+                <a:solidFill>
+                  <a:srgbClr val="6B7280"/>
+                </a:solidFill>
+                <a:latin typeface="Helvetica"/>
+              </a:rPr>
+              <a:t>zero cloud on the critical path.</a:t>
+            </a:r>
+          </a:p>
+        </p:txBody>
+      </p:sp>
+    </p:spTree>
+  </p:cSld>
+  <p:clrMapOvr>
+    <a:masterClrMapping/>
+  </p:clrMapOvr>
+</p:sld>
+</file>
+
+<file path=ppt/slides/slide12.xml><?xml version="1.0" encoding="utf-8"?>
 <p:sld xmlns:a="http://schemas.openxmlformats.org/drawingml/2006/main" xmlns:p="http://schemas.openxmlformats.org/presentationml/2006/main" xmlns:r="http://schemas.openxmlformats.org/officeDocument/2006/relationships">
   <p:cSld>
     <p:bg>
@@ -3875,7 +4461,7 @@
                 </a:solidFill>
                 <a:latin typeface="Helvetica"/>
               </a:rPr>
-              <a:t>—  Blocked from bars, hospitals, therapy offices</a:t>
+              <a:t>—  Banned from bars, hospitals, therapy</a:t>
             </a:r>
           </a:p>
           <a:p>
@@ -3965,7 +4551,7 @@
                 </a:solidFill>
                 <a:latin typeface="Helvetica"/>
               </a:rPr>
-              <a:t>—  Cameraless by physics — G2 has no lens</a:t>
+              <a:t>—  Cameraless by physics</a:t>
             </a:r>
           </a:p>
           <a:p>
@@ -3997,7 +4583,7 @@
                 </a:solidFill>
                 <a:latin typeface="Helvetica"/>
               </a:rPr>
-              <a:t>—  Only remembers people you chose to remember</a:t>
+              <a:t>—  Only remembers people you enrolled</a:t>
             </a:r>
           </a:p>
         </p:txBody>

</xml_diff>

<commit_message>
pitch: add 'Two Ways to Recall' slide (push + pull) between HUD states and flow
</commit_message>
<xml_diff>
--- a/docs/Cue-Pitch.pptx
+++ b/docs/Cue-Pitch.pptx
@@ -17,6 +17,7 @@
     <p:sldId id="265" r:id="rId16"/>
     <p:sldId id="266" r:id="rId17"/>
     <p:sldId id="267" r:id="rId18"/>
+    <p:sldId id="268" r:id="rId19"/>
   </p:sldIdLst>
   <p:sldSz cx="12191695" cy="6858000" type="screen4x3"/>
   <p:notesSz cx="6858000" cy="9144000"/>
@@ -3268,7 +3269,7 @@
                 </a:solidFill>
                 <a:latin typeface="Helvetica"/>
               </a:rPr>
-              <a:t>WHY THIS RESONATES</a:t>
+              <a:t>PRIVACY, BY DESIGN</a:t>
             </a:r>
           </a:p>
         </p:txBody>
@@ -3282,7 +3283,7 @@
         <p:spPr>
           <a:xfrm>
             <a:off x="640080" y="1097280"/>
-            <a:ext cx="10972800" cy="914400"/>
+            <a:ext cx="10972800" cy="1280160"/>
           </a:xfrm>
           <a:prstGeom prst="rect">
             <a:avLst/>
@@ -3303,7 +3304,8 @@
                 </a:solidFill>
                 <a:latin typeface="Helvetica"/>
               </a:rPr>
-              <a:t>Cue is the room.</a:t>
+              <a:t>Cue only remembers people
+you chose to remember.</a:t>
             </a:r>
           </a:p>
         </p:txBody>
@@ -3316,8 +3318,8 @@
         </p:nvSpPr>
         <p:spPr>
           <a:xfrm>
-            <a:off x="640080" y="2560320"/>
-            <a:ext cx="10972800" cy="3657600"/>
+            <a:off x="640080" y="3931920"/>
+            <a:ext cx="10972800" cy="2743200"/>
           </a:xfrm>
           <a:prstGeom prst="rect">
             <a:avLst/>
@@ -3336,13 +3338,13 @@
               </a:spcAft>
             </a:pPr>
             <a:r>
-              <a:rPr sz="2200">
+              <a:rPr sz="2000">
                 <a:solidFill>
                   <a:srgbClr val="0E0E0E"/>
                 </a:solidFill>
                 <a:latin typeface="Helvetica"/>
               </a:rPr>
-              <a:t>—  Everyone here forgot someone's name this week.</a:t>
+              <a:t>—  Explicit enrollment — no row is written without a temple tap</a:t>
             </a:r>
           </a:p>
           <a:p>
@@ -3352,13 +3354,13 @@
               </a:spcAft>
             </a:pPr>
             <a:r>
-              <a:rPr sz="2200">
+              <a:rPr sz="2000">
                 <a:solidFill>
                   <a:srgbClr val="0E0E0E"/>
                 </a:solidFill>
                 <a:latin typeface="Helvetica"/>
               </a:rPr>
-              <a:t>—  You walked into 40 intros today. You'll forget 34.</a:t>
+              <a:t>—  Local-first — ~/.cue/people.db lives on your phone. One-tap delete.</a:t>
             </a:r>
           </a:p>
           <a:p>
@@ -3368,13 +3370,13 @@
               </a:spcAft>
             </a:pPr>
             <a:r>
-              <a:rPr sz="2200">
+              <a:rPr sz="2000">
                 <a:solidFill>
                   <a:srgbClr val="0E0E0E"/>
                 </a:solidFill>
                 <a:latin typeface="Helvetica"/>
               </a:rPr>
-              <a:t>—  Meta tried cameras — they get you thrown out of the room.</a:t>
+              <a:t>—  Cameraless by physics — the G2 has no lens. No face database exists.</a:t>
             </a:r>
           </a:p>
           <a:p>
@@ -3384,13 +3386,13 @@
               </a:spcAft>
             </a:pPr>
             <a:r>
-              <a:rPr sz="2200">
+              <a:rPr sz="2000">
                 <a:solidFill>
                   <a:srgbClr val="0E0E0E"/>
                 </a:solidFill>
                 <a:latin typeface="Helvetica"/>
               </a:rPr>
-              <a:t>—  G2 stays in. Cue is Quiet Tech rendered as product.</a:t>
+              <a:t>—  No network on the critical path. Claude used only for optional summaries.</a:t>
             </a:r>
           </a:p>
         </p:txBody>
@@ -3451,6 +3453,189 @@
                 </a:solidFill>
                 <a:latin typeface="Helvetica"/>
               </a:rPr>
+              <a:t>WHY THIS RESONATES</a:t>
+            </a:r>
+          </a:p>
+        </p:txBody>
+      </p:sp>
+      <p:sp>
+        <p:nvSpPr>
+          <p:cNvPr id="3" name="TextBox 2"/>
+          <p:cNvSpPr txBox="1"/>
+          <p:nvPr/>
+        </p:nvSpPr>
+        <p:spPr>
+          <a:xfrm>
+            <a:off x="640080" y="1097280"/>
+            <a:ext cx="10972800" cy="914400"/>
+          </a:xfrm>
+          <a:prstGeom prst="rect">
+            <a:avLst/>
+          </a:prstGeom>
+          <a:noFill/>
+        </p:spPr>
+        <p:txBody>
+          <a:bodyPr wrap="square" lIns="0" rIns="0">
+            <a:spAutoFit/>
+          </a:bodyPr>
+          <a:lstStyle/>
+          <a:p>
+            <a:pPr algn="l"/>
+            <a:r>
+              <a:rPr sz="4400" b="1">
+                <a:solidFill>
+                  <a:srgbClr val="0E0E0E"/>
+                </a:solidFill>
+                <a:latin typeface="Helvetica"/>
+              </a:rPr>
+              <a:t>Cue is the room.</a:t>
+            </a:r>
+          </a:p>
+        </p:txBody>
+      </p:sp>
+      <p:sp>
+        <p:nvSpPr>
+          <p:cNvPr id="4" name="TextBox 3"/>
+          <p:cNvSpPr txBox="1"/>
+          <p:nvPr/>
+        </p:nvSpPr>
+        <p:spPr>
+          <a:xfrm>
+            <a:off x="640080" y="2560320"/>
+            <a:ext cx="10972800" cy="3657600"/>
+          </a:xfrm>
+          <a:prstGeom prst="rect">
+            <a:avLst/>
+          </a:prstGeom>
+          <a:noFill/>
+        </p:spPr>
+        <p:txBody>
+          <a:bodyPr wrap="square">
+            <a:spAutoFit/>
+          </a:bodyPr>
+          <a:lstStyle/>
+          <a:p>
+            <a:pPr algn="l">
+              <a:spcAft>
+                <a:spcPts val="800"/>
+              </a:spcAft>
+            </a:pPr>
+            <a:r>
+              <a:rPr sz="2200">
+                <a:solidFill>
+                  <a:srgbClr val="0E0E0E"/>
+                </a:solidFill>
+                <a:latin typeface="Helvetica"/>
+              </a:rPr>
+              <a:t>—  Everyone here forgot someone's name this week.</a:t>
+            </a:r>
+          </a:p>
+          <a:p>
+            <a:pPr algn="l">
+              <a:spcAft>
+                <a:spcPts val="800"/>
+              </a:spcAft>
+            </a:pPr>
+            <a:r>
+              <a:rPr sz="2200">
+                <a:solidFill>
+                  <a:srgbClr val="0E0E0E"/>
+                </a:solidFill>
+                <a:latin typeface="Helvetica"/>
+              </a:rPr>
+              <a:t>—  You walked into 40 intros today. You'll forget 34.</a:t>
+            </a:r>
+          </a:p>
+          <a:p>
+            <a:pPr algn="l">
+              <a:spcAft>
+                <a:spcPts val="800"/>
+              </a:spcAft>
+            </a:pPr>
+            <a:r>
+              <a:rPr sz="2200">
+                <a:solidFill>
+                  <a:srgbClr val="0E0E0E"/>
+                </a:solidFill>
+                <a:latin typeface="Helvetica"/>
+              </a:rPr>
+              <a:t>—  Meta tried cameras — they get you thrown out of the room.</a:t>
+            </a:r>
+          </a:p>
+          <a:p>
+            <a:pPr algn="l">
+              <a:spcAft>
+                <a:spcPts val="800"/>
+              </a:spcAft>
+            </a:pPr>
+            <a:r>
+              <a:rPr sz="2200">
+                <a:solidFill>
+                  <a:srgbClr val="0E0E0E"/>
+                </a:solidFill>
+                <a:latin typeface="Helvetica"/>
+              </a:rPr>
+              <a:t>—  G2 stays in. Cue is Quiet Tech rendered as product.</a:t>
+            </a:r>
+          </a:p>
+        </p:txBody>
+      </p:sp>
+    </p:spTree>
+  </p:cSld>
+  <p:clrMapOvr>
+    <a:masterClrMapping/>
+  </p:clrMapOvr>
+</p:sld>
+</file>
+
+<file path=ppt/slides/slide12.xml><?xml version="1.0" encoding="utf-8"?>
+<p:sld xmlns:a="http://schemas.openxmlformats.org/drawingml/2006/main" xmlns:p="http://schemas.openxmlformats.org/presentationml/2006/main" xmlns:r="http://schemas.openxmlformats.org/officeDocument/2006/relationships">
+  <p:cSld>
+    <p:bg>
+      <p:bgPr>
+        <a:solidFill>
+          <a:srgbClr val="FAFAFA"/>
+        </a:solidFill>
+        <a:effectLst/>
+      </p:bgPr>
+    </p:bg>
+    <p:spTree>
+      <p:nvGrpSpPr>
+        <p:cNvPr id="1" name=""/>
+        <p:cNvGrpSpPr/>
+        <p:nvPr/>
+      </p:nvGrpSpPr>
+      <p:grpSpPr/>
+      <p:sp>
+        <p:nvSpPr>
+          <p:cNvPr id="2" name="TextBox 1"/>
+          <p:cNvSpPr txBox="1"/>
+          <p:nvPr/>
+        </p:nvSpPr>
+        <p:spPr>
+          <a:xfrm>
+            <a:off x="640080" y="548640"/>
+            <a:ext cx="10972800" cy="457200"/>
+          </a:xfrm>
+          <a:prstGeom prst="rect">
+            <a:avLst/>
+          </a:prstGeom>
+          <a:noFill/>
+        </p:spPr>
+        <p:txBody>
+          <a:bodyPr wrap="square" lIns="0" rIns="0">
+            <a:spAutoFit/>
+          </a:bodyPr>
+          <a:lstStyle/>
+          <a:p>
+            <a:pPr algn="l"/>
+            <a:r>
+              <a:rPr sz="1200" b="1">
+                <a:solidFill>
+                  <a:srgbClr val="00B86F"/>
+                </a:solidFill>
+                <a:latin typeface="Helvetica"/>
+              </a:rPr>
               <a:t>WHAT'S NEXT</a:t>
             </a:r>
           </a:p>
@@ -3988,7 +4173,7 @@
 </p:sld>
 </file>
 
-<file path=ppt/slides/slide12.xml><?xml version="1.0" encoding="utf-8"?>
+<file path=ppt/slides/slide13.xml><?xml version="1.0" encoding="utf-8"?>
 <p:sld xmlns:a="http://schemas.openxmlformats.org/drawingml/2006/main" xmlns:p="http://schemas.openxmlformats.org/presentationml/2006/main" xmlns:r="http://schemas.openxmlformats.org/officeDocument/2006/relationships">
   <p:cSld>
     <p:bg>
@@ -5265,6 +5450,381 @@
         </p:nvSpPr>
         <p:spPr>
           <a:xfrm>
+            <a:off x="640080" y="365760"/>
+            <a:ext cx="10972800" cy="457200"/>
+          </a:xfrm>
+          <a:prstGeom prst="rect">
+            <a:avLst/>
+          </a:prstGeom>
+          <a:noFill/>
+        </p:spPr>
+        <p:txBody>
+          <a:bodyPr wrap="square" lIns="0" rIns="0">
+            <a:spAutoFit/>
+          </a:bodyPr>
+          <a:lstStyle/>
+          <a:p>
+            <a:pPr algn="l"/>
+            <a:r>
+              <a:rPr sz="1200" b="1">
+                <a:solidFill>
+                  <a:srgbClr val="00B86F"/>
+                </a:solidFill>
+                <a:latin typeface="Helvetica"/>
+              </a:rPr>
+              <a:t>TWO WAYS TO RECALL</a:t>
+            </a:r>
+          </a:p>
+        </p:txBody>
+      </p:sp>
+      <p:sp>
+        <p:nvSpPr>
+          <p:cNvPr id="3" name="TextBox 2"/>
+          <p:cNvSpPr txBox="1"/>
+          <p:nvPr/>
+        </p:nvSpPr>
+        <p:spPr>
+          <a:xfrm>
+            <a:off x="640080" y="822960"/>
+            <a:ext cx="10972800" cy="731520"/>
+          </a:xfrm>
+          <a:prstGeom prst="rect">
+            <a:avLst/>
+          </a:prstGeom>
+          <a:noFill/>
+        </p:spPr>
+        <p:txBody>
+          <a:bodyPr wrap="square" lIns="0" rIns="0">
+            <a:spAutoFit/>
+          </a:bodyPr>
+          <a:lstStyle/>
+          <a:p>
+            <a:pPr algn="l"/>
+            <a:r>
+              <a:rPr sz="2800" b="1">
+                <a:solidFill>
+                  <a:srgbClr val="0E0E0E"/>
+                </a:solidFill>
+                <a:latin typeface="Helvetica"/>
+              </a:rPr>
+              <a:t>Not just a notification. A memory surface.</a:t>
+            </a:r>
+          </a:p>
+        </p:txBody>
+      </p:sp>
+      <p:sp>
+        <p:nvSpPr>
+          <p:cNvPr id="4" name="TextBox 3"/>
+          <p:cNvSpPr txBox="1"/>
+          <p:nvPr/>
+        </p:nvSpPr>
+        <p:spPr>
+          <a:xfrm>
+            <a:off x="640080" y="1920240"/>
+            <a:ext cx="5303520" cy="365760"/>
+          </a:xfrm>
+          <a:prstGeom prst="rect">
+            <a:avLst/>
+          </a:prstGeom>
+          <a:noFill/>
+        </p:spPr>
+        <p:txBody>
+          <a:bodyPr wrap="square" lIns="0" rIns="0">
+            <a:spAutoFit/>
+          </a:bodyPr>
+          <a:lstStyle/>
+          <a:p>
+            <a:pPr algn="l"/>
+            <a:r>
+              <a:rPr sz="1800" b="1">
+                <a:solidFill>
+                  <a:srgbClr val="6B7280"/>
+                </a:solidFill>
+                <a:latin typeface="Helvetica"/>
+              </a:rPr>
+              <a:t>Push  —  voice triggers it</a:t>
+            </a:r>
+          </a:p>
+        </p:txBody>
+      </p:sp>
+      <p:sp>
+        <p:nvSpPr>
+          <p:cNvPr id="5" name="TextBox 4"/>
+          <p:cNvSpPr txBox="1"/>
+          <p:nvPr/>
+        </p:nvSpPr>
+        <p:spPr>
+          <a:xfrm>
+            <a:off x="640080" y="2377440"/>
+            <a:ext cx="5303520" cy="2743200"/>
+          </a:xfrm>
+          <a:prstGeom prst="rect">
+            <a:avLst/>
+          </a:prstGeom>
+          <a:noFill/>
+        </p:spPr>
+        <p:txBody>
+          <a:bodyPr wrap="square">
+            <a:spAutoFit/>
+          </a:bodyPr>
+          <a:lstStyle/>
+          <a:p>
+            <a:pPr algn="l">
+              <a:spcAft>
+                <a:spcPts val="800"/>
+              </a:spcAft>
+            </a:pPr>
+            <a:r>
+              <a:rPr sz="1800">
+                <a:solidFill>
+                  <a:srgbClr val="0E0E0E"/>
+                </a:solidFill>
+                <a:latin typeface="Helvetica"/>
+              </a:rPr>
+              <a:t>—  Someone speaks near you</a:t>
+            </a:r>
+          </a:p>
+          <a:p>
+            <a:pPr algn="l">
+              <a:spcAft>
+                <a:spcPts val="800"/>
+              </a:spcAft>
+            </a:pPr>
+            <a:r>
+              <a:rPr sz="1800">
+                <a:solidFill>
+                  <a:srgbClr val="0E0E0E"/>
+                </a:solidFill>
+                <a:latin typeface="Helvetica"/>
+              </a:rPr>
+              <a:t>—  Cue matches their voiceprint</a:t>
+            </a:r>
+          </a:p>
+          <a:p>
+            <a:pPr algn="l">
+              <a:spcAft>
+                <a:spcPts val="800"/>
+              </a:spcAft>
+            </a:pPr>
+            <a:r>
+              <a:rPr sz="1800">
+                <a:solidFill>
+                  <a:srgbClr val="0E0E0E"/>
+                </a:solidFill>
+                <a:latin typeface="Helvetica"/>
+              </a:rPr>
+              <a:t>—  Card fades onto your HUD in ≤1.5s</a:t>
+            </a:r>
+          </a:p>
+          <a:p>
+            <a:pPr algn="l">
+              <a:spcAft>
+                <a:spcPts val="800"/>
+              </a:spcAft>
+            </a:pPr>
+            <a:r>
+              <a:rPr sz="1800">
+                <a:solidFill>
+                  <a:srgbClr val="0E0E0E"/>
+                </a:solidFill>
+                <a:latin typeface="Helvetica"/>
+              </a:rPr>
+              <a:t>—  You read, react, converse</a:t>
+            </a:r>
+          </a:p>
+        </p:txBody>
+      </p:sp>
+      <p:sp>
+        <p:nvSpPr>
+          <p:cNvPr id="6" name="TextBox 5"/>
+          <p:cNvSpPr txBox="1"/>
+          <p:nvPr/>
+        </p:nvSpPr>
+        <p:spPr>
+          <a:xfrm>
+            <a:off x="6400800" y="1920240"/>
+            <a:ext cx="5303520" cy="365760"/>
+          </a:xfrm>
+          <a:prstGeom prst="rect">
+            <a:avLst/>
+          </a:prstGeom>
+          <a:noFill/>
+        </p:spPr>
+        <p:txBody>
+          <a:bodyPr wrap="square" lIns="0" rIns="0">
+            <a:spAutoFit/>
+          </a:bodyPr>
+          <a:lstStyle/>
+          <a:p>
+            <a:pPr algn="l"/>
+            <a:r>
+              <a:rPr sz="1800" b="1">
+                <a:solidFill>
+                  <a:srgbClr val="00B86F"/>
+                </a:solidFill>
+                <a:latin typeface="Helvetica"/>
+              </a:rPr>
+              <a:t>Pull  —  you ask for it</a:t>
+            </a:r>
+          </a:p>
+        </p:txBody>
+      </p:sp>
+      <p:sp>
+        <p:nvSpPr>
+          <p:cNvPr id="7" name="TextBox 6"/>
+          <p:cNvSpPr txBox="1"/>
+          <p:nvPr/>
+        </p:nvSpPr>
+        <p:spPr>
+          <a:xfrm>
+            <a:off x="6400800" y="2377440"/>
+            <a:ext cx="5303520" cy="2743200"/>
+          </a:xfrm>
+          <a:prstGeom prst="rect">
+            <a:avLst/>
+          </a:prstGeom>
+          <a:noFill/>
+        </p:spPr>
+        <p:txBody>
+          <a:bodyPr wrap="square">
+            <a:spAutoFit/>
+          </a:bodyPr>
+          <a:lstStyle/>
+          <a:p>
+            <a:pPr algn="l">
+              <a:spcAft>
+                <a:spcPts val="800"/>
+              </a:spcAft>
+            </a:pPr>
+            <a:r>
+              <a:rPr sz="1800">
+                <a:solidFill>
+                  <a:srgbClr val="0E0E0E"/>
+                </a:solidFill>
+                <a:latin typeface="Helvetica"/>
+              </a:rPr>
+              <a:t>—  Triple-tap your right temple</a:t>
+            </a:r>
+          </a:p>
+          <a:p>
+            <a:pPr algn="l">
+              <a:spcAft>
+                <a:spcPts val="800"/>
+              </a:spcAft>
+            </a:pPr>
+            <a:r>
+              <a:rPr sz="1800">
+                <a:solidFill>
+                  <a:srgbClr val="0E0E0E"/>
+                </a:solidFill>
+                <a:latin typeface="Helvetica"/>
+              </a:rPr>
+              <a:t>—  Most-recent person fills the HUD</a:t>
+            </a:r>
+          </a:p>
+          <a:p>
+            <a:pPr algn="l">
+              <a:spcAft>
+                <a:spcPts val="800"/>
+              </a:spcAft>
+            </a:pPr>
+            <a:r>
+              <a:rPr sz="1800">
+                <a:solidFill>
+                  <a:srgbClr val="0E0E0E"/>
+                </a:solidFill>
+                <a:latin typeface="Helvetica"/>
+              </a:rPr>
+              <a:t>—  Cycle to older contacts with more taps</a:t>
+            </a:r>
+          </a:p>
+          <a:p>
+            <a:pPr algn="l">
+              <a:spcAft>
+                <a:spcPts val="800"/>
+              </a:spcAft>
+            </a:pPr>
+            <a:r>
+              <a:rPr sz="1800">
+                <a:solidFill>
+                  <a:srgbClr val="0E0E0E"/>
+                </a:solidFill>
+                <a:latin typeface="Helvetica"/>
+              </a:rPr>
+              <a:t>—  Before you walk into the next meeting</a:t>
+            </a:r>
+          </a:p>
+        </p:txBody>
+      </p:sp>
+      <p:sp>
+        <p:nvSpPr>
+          <p:cNvPr id="8" name="TextBox 7"/>
+          <p:cNvSpPr txBox="1"/>
+          <p:nvPr/>
+        </p:nvSpPr>
+        <p:spPr>
+          <a:xfrm>
+            <a:off x="640080" y="5669280"/>
+            <a:ext cx="10972800" cy="457200"/>
+          </a:xfrm>
+          <a:prstGeom prst="rect">
+            <a:avLst/>
+          </a:prstGeom>
+          <a:noFill/>
+        </p:spPr>
+        <p:txBody>
+          <a:bodyPr wrap="square" lIns="0" rIns="0">
+            <a:spAutoFit/>
+          </a:bodyPr>
+          <a:lstStyle/>
+          <a:p>
+            <a:pPr algn="ctr"/>
+            <a:r>
+              <a:rPr sz="1800" b="0">
+                <a:solidFill>
+                  <a:srgbClr val="6B7280"/>
+                </a:solidFill>
+                <a:latin typeface="Helvetica"/>
+              </a:rPr>
+              <a:t>A memory you trust. Not a notification you react to.</a:t>
+            </a:r>
+          </a:p>
+        </p:txBody>
+      </p:sp>
+    </p:spTree>
+  </p:cSld>
+  <p:clrMapOvr>
+    <a:masterClrMapping/>
+  </p:clrMapOvr>
+</p:sld>
+</file>
+
+<file path=ppt/slides/slide8.xml><?xml version="1.0" encoding="utf-8"?>
+<p:sld xmlns:a="http://schemas.openxmlformats.org/drawingml/2006/main" xmlns:p="http://schemas.openxmlformats.org/presentationml/2006/main" xmlns:r="http://schemas.openxmlformats.org/officeDocument/2006/relationships">
+  <p:cSld>
+    <p:bg>
+      <p:bgPr>
+        <a:solidFill>
+          <a:srgbClr val="FAFAFA"/>
+        </a:solidFill>
+        <a:effectLst/>
+      </p:bgPr>
+    </p:bg>
+    <p:spTree>
+      <p:nvGrpSpPr>
+        <p:cNvPr id="1" name=""/>
+        <p:cNvGrpSpPr/>
+        <p:nvPr/>
+      </p:nvGrpSpPr>
+      <p:grpSpPr/>
+      <p:sp>
+        <p:nvSpPr>
+          <p:cNvPr id="2" name="TextBox 1"/>
+          <p:cNvSpPr txBox="1"/>
+          <p:nvPr/>
+        </p:nvSpPr>
+        <p:spPr>
+          <a:xfrm>
             <a:off x="640080" y="274320"/>
             <a:ext cx="10972800" cy="457200"/>
           </a:xfrm>
@@ -5324,7 +5884,7 @@
 </p:sld>
 </file>
 
-<file path=ppt/slides/slide8.xml><?xml version="1.0" encoding="utf-8"?>
+<file path=ppt/slides/slide9.xml><?xml version="1.0" encoding="utf-8"?>
 <p:sld xmlns:a="http://schemas.openxmlformats.org/drawingml/2006/main" xmlns:p="http://schemas.openxmlformats.org/presentationml/2006/main" xmlns:r="http://schemas.openxmlformats.org/officeDocument/2006/relationships">
   <p:cSld>
     <p:bg>
@@ -5436,190 +5996,6 @@
           </a:prstGeom>
         </p:spPr>
       </p:pic>
-    </p:spTree>
-  </p:cSld>
-  <p:clrMapOvr>
-    <a:masterClrMapping/>
-  </p:clrMapOvr>
-</p:sld>
-</file>
-
-<file path=ppt/slides/slide9.xml><?xml version="1.0" encoding="utf-8"?>
-<p:sld xmlns:a="http://schemas.openxmlformats.org/drawingml/2006/main" xmlns:p="http://schemas.openxmlformats.org/presentationml/2006/main" xmlns:r="http://schemas.openxmlformats.org/officeDocument/2006/relationships">
-  <p:cSld>
-    <p:bg>
-      <p:bgPr>
-        <a:solidFill>
-          <a:srgbClr val="FAFAFA"/>
-        </a:solidFill>
-        <a:effectLst/>
-      </p:bgPr>
-    </p:bg>
-    <p:spTree>
-      <p:nvGrpSpPr>
-        <p:cNvPr id="1" name=""/>
-        <p:cNvGrpSpPr/>
-        <p:nvPr/>
-      </p:nvGrpSpPr>
-      <p:grpSpPr/>
-      <p:sp>
-        <p:nvSpPr>
-          <p:cNvPr id="2" name="TextBox 1"/>
-          <p:cNvSpPr txBox="1"/>
-          <p:nvPr/>
-        </p:nvSpPr>
-        <p:spPr>
-          <a:xfrm>
-            <a:off x="640080" y="548640"/>
-            <a:ext cx="10972800" cy="457200"/>
-          </a:xfrm>
-          <a:prstGeom prst="rect">
-            <a:avLst/>
-          </a:prstGeom>
-          <a:noFill/>
-        </p:spPr>
-        <p:txBody>
-          <a:bodyPr wrap="square" lIns="0" rIns="0">
-            <a:spAutoFit/>
-          </a:bodyPr>
-          <a:lstStyle/>
-          <a:p>
-            <a:pPr algn="l"/>
-            <a:r>
-              <a:rPr sz="1200" b="1">
-                <a:solidFill>
-                  <a:srgbClr val="00B86F"/>
-                </a:solidFill>
-                <a:latin typeface="Helvetica"/>
-              </a:rPr>
-              <a:t>PRIVACY, BY DESIGN</a:t>
-            </a:r>
-          </a:p>
-        </p:txBody>
-      </p:sp>
-      <p:sp>
-        <p:nvSpPr>
-          <p:cNvPr id="3" name="TextBox 2"/>
-          <p:cNvSpPr txBox="1"/>
-          <p:nvPr/>
-        </p:nvSpPr>
-        <p:spPr>
-          <a:xfrm>
-            <a:off x="640080" y="1097280"/>
-            <a:ext cx="10972800" cy="1280160"/>
-          </a:xfrm>
-          <a:prstGeom prst="rect">
-            <a:avLst/>
-          </a:prstGeom>
-          <a:noFill/>
-        </p:spPr>
-        <p:txBody>
-          <a:bodyPr wrap="square" lIns="0" rIns="0">
-            <a:spAutoFit/>
-          </a:bodyPr>
-          <a:lstStyle/>
-          <a:p>
-            <a:pPr algn="l"/>
-            <a:r>
-              <a:rPr sz="4400" b="1">
-                <a:solidFill>
-                  <a:srgbClr val="0E0E0E"/>
-                </a:solidFill>
-                <a:latin typeface="Helvetica"/>
-              </a:rPr>
-              <a:t>Cue only remembers people
-you chose to remember.</a:t>
-            </a:r>
-          </a:p>
-        </p:txBody>
-      </p:sp>
-      <p:sp>
-        <p:nvSpPr>
-          <p:cNvPr id="4" name="TextBox 3"/>
-          <p:cNvSpPr txBox="1"/>
-          <p:nvPr/>
-        </p:nvSpPr>
-        <p:spPr>
-          <a:xfrm>
-            <a:off x="640080" y="3931920"/>
-            <a:ext cx="10972800" cy="2743200"/>
-          </a:xfrm>
-          <a:prstGeom prst="rect">
-            <a:avLst/>
-          </a:prstGeom>
-          <a:noFill/>
-        </p:spPr>
-        <p:txBody>
-          <a:bodyPr wrap="square">
-            <a:spAutoFit/>
-          </a:bodyPr>
-          <a:lstStyle/>
-          <a:p>
-            <a:pPr algn="l">
-              <a:spcAft>
-                <a:spcPts val="800"/>
-              </a:spcAft>
-            </a:pPr>
-            <a:r>
-              <a:rPr sz="2000">
-                <a:solidFill>
-                  <a:srgbClr val="0E0E0E"/>
-                </a:solidFill>
-                <a:latin typeface="Helvetica"/>
-              </a:rPr>
-              <a:t>—  Explicit enrollment — no row is written without a temple tap</a:t>
-            </a:r>
-          </a:p>
-          <a:p>
-            <a:pPr algn="l">
-              <a:spcAft>
-                <a:spcPts val="800"/>
-              </a:spcAft>
-            </a:pPr>
-            <a:r>
-              <a:rPr sz="2000">
-                <a:solidFill>
-                  <a:srgbClr val="0E0E0E"/>
-                </a:solidFill>
-                <a:latin typeface="Helvetica"/>
-              </a:rPr>
-              <a:t>—  Local-first — ~/.cue/people.db lives on your phone. One-tap delete.</a:t>
-            </a:r>
-          </a:p>
-          <a:p>
-            <a:pPr algn="l">
-              <a:spcAft>
-                <a:spcPts val="800"/>
-              </a:spcAft>
-            </a:pPr>
-            <a:r>
-              <a:rPr sz="2000">
-                <a:solidFill>
-                  <a:srgbClr val="0E0E0E"/>
-                </a:solidFill>
-                <a:latin typeface="Helvetica"/>
-              </a:rPr>
-              <a:t>—  Cameraless by physics — the G2 has no lens. No face database exists.</a:t>
-            </a:r>
-          </a:p>
-          <a:p>
-            <a:pPr algn="l">
-              <a:spcAft>
-                <a:spcPts val="800"/>
-              </a:spcAft>
-            </a:pPr>
-            <a:r>
-              <a:rPr sz="2000">
-                <a:solidFill>
-                  <a:srgbClr val="0E0E0E"/>
-                </a:solidFill>
-                <a:latin typeface="Helvetica"/>
-              </a:rPr>
-              <a:t>—  No network on the critical path. Claude used only for optional summaries.</a:t>
-            </a:r>
-          </a:p>
-        </p:txBody>
-      </p:sp>
     </p:spTree>
   </p:cSld>
   <p:clrMapOvr>

</xml_diff>